<commit_message>
Update decks and expand operational runbooks
- Updated all 9 presentation decks with additional content
- Expanded DR, Incident Response, and Model Degradation runbooks

Co-Authored-By: Claude Opus 4.6 (1M context) <noreply@anthropic.com>
</commit_message>
<xml_diff>
--- a/decks/SLG-01-Resident-Services-311.pptx
+++ b/decks/SLG-01-Resident-Services-311.pptx
@@ -4184,7 +4184,7 @@
         </p:nvSpPr>
         <p:spPr>
           <a:xfrm>
-            <a:off x="640080" y="365760"/>
+            <a:off x="457200" y="256032"/>
             <a:ext cx="10972800" cy="274320"/>
           </a:xfrm>
           <a:prstGeom prst="rect">
@@ -4220,8 +4220,8 @@
         </p:nvSpPr>
         <p:spPr>
           <a:xfrm>
-            <a:off x="640080" y="658368"/>
-            <a:ext cx="10972800" cy="502920"/>
+            <a:off x="457200" y="530352"/>
+            <a:ext cx="11338560" cy="457200"/>
           </a:xfrm>
           <a:prstGeom prst="rect">
             <a:avLst/>
@@ -4237,7 +4237,7 @@
               <a:buNone/>
             </a:pPr>
             <a:r>
-              <a:rPr lang="en-US" sz="2000" b="1" dirty="0">
+              <a:rPr lang="en-US" sz="1800" b="1" dirty="0">
                 <a:solidFill>
                   <a:srgbClr val="1B2440"/>
                 </a:solidFill>
@@ -4247,7 +4247,7 @@
               </a:rPr>
               <a:t>Resident Services &amp; 311 Navigator</a:t>
             </a:r>
-            <a:endParaRPr lang="en-US" sz="2000" dirty="0"/>
+            <a:endParaRPr lang="en-US" sz="1800" dirty="0"/>
           </a:p>
         </p:txBody>
       </p:sp>
@@ -4259,12 +4259,12 @@
         </p:nvSpPr>
         <p:spPr>
           <a:xfrm>
-            <a:off x="640080" y="1078992"/>
-            <a:ext cx="10881360" cy="384048"/>
+            <a:off x="457200" y="950976"/>
+            <a:ext cx="11274552" cy="365760"/>
           </a:xfrm>
           <a:prstGeom prst="roundRect">
             <a:avLst>
-              <a:gd name="adj" fmla="val 11905"/>
+              <a:gd name="adj" fmla="val 10000"/>
             </a:avLst>
           </a:prstGeom>
           <a:solidFill>
@@ -4281,8 +4281,8 @@
         </p:nvSpPr>
         <p:spPr>
           <a:xfrm>
-            <a:off x="841248" y="1078992"/>
-            <a:ext cx="10515600" cy="384048"/>
+            <a:off x="640080" y="950976"/>
+            <a:ext cx="10972800" cy="365760"/>
           </a:xfrm>
           <a:prstGeom prst="rect">
             <a:avLst/>
@@ -4298,7 +4298,7 @@
               <a:buNone/>
             </a:pPr>
             <a:r>
-              <a:rPr lang="en-US" sz="950" b="1" dirty="0">
+              <a:rPr lang="en-US" sz="900" b="1" dirty="0">
                 <a:solidFill>
                   <a:srgbClr val="9A6B12"/>
                 </a:solidFill>
@@ -4309,14 +4309,14 @@
               <a:buNone/>
             </a:pPr>
             <a:r>
-              <a:rPr lang="en-US" sz="950" dirty="0">
+              <a:rPr lang="en-US" sz="900" dirty="0">
                 <a:solidFill>
                   <a:srgbClr val="5B4708"/>
                 </a:solidFill>
               </a:rPr>
-              <a:t>STANDALONE-DEPLOYABLE — this agent ships its OWN VPC · Flow Logs · Bedrock VPC endpoint · KMS · Bedrock Guardrail · append-only audit + S3 Object Lock (WORM) · deny-by-default gateway · human gate. No WoG dependency; the Whole-of-Government platform is optional and additive.</a:t>
-            </a:r>
-            <a:endParaRPr lang="en-US" sz="950" dirty="0"/>
+              <a:t>STANDALONE-DEPLOYABLE — own VPC · CloudFront + WAF edge · KMS · WORM audit · gateway · human gate. No WoG dependency; the Whole-of-Government platform is optional and additive.</a:t>
+            </a:r>
+            <a:endParaRPr lang="en-US" sz="900" dirty="0"/>
           </a:p>
         </p:txBody>
       </p:sp>
@@ -4328,12 +4328,75 @@
         </p:nvSpPr>
         <p:spPr>
           <a:xfrm>
-            <a:off x="640080" y="1572768"/>
-            <a:ext cx="10881360" cy="512064"/>
+            <a:off x="457200" y="1444752"/>
+            <a:ext cx="1993392" cy="3310128"/>
           </a:xfrm>
           <a:prstGeom prst="roundRect">
             <a:avLst>
-              <a:gd name="adj" fmla="val 8929"/>
+              <a:gd name="adj" fmla="val 2294"/>
+            </a:avLst>
+          </a:prstGeom>
+          <a:solidFill>
+            <a:srgbClr val="F4F7FE"/>
+          </a:solidFill>
+          <a:ln w="12700">
+            <a:solidFill>
+              <a:srgbClr val="C2D0EC"/>
+            </a:solidFill>
+            <a:prstDash val="solid"/>
+          </a:ln>
+        </p:spPr>
+      </p:sp>
+      <p:sp>
+        <p:nvSpPr>
+          <p:cNvPr id="7" name="Text 5"/>
+          <p:cNvSpPr/>
+          <p:nvPr/>
+        </p:nvSpPr>
+        <p:spPr>
+          <a:xfrm>
+            <a:off x="566928" y="1499616"/>
+            <a:ext cx="1773936" cy="219456"/>
+          </a:xfrm>
+          <a:prstGeom prst="rect">
+            <a:avLst/>
+          </a:prstGeom>
+          <a:noFill/>
+          <a:ln/>
+        </p:spPr>
+        <p:txBody>
+          <a:bodyPr wrap="square" rtlCol="0" anchor="ctr"/>
+          <a:lstStyle/>
+          <a:p>
+            <a:pPr indent="0" marL="0">
+              <a:buNone/>
+            </a:pPr>
+            <a:r>
+              <a:rPr lang="en-US" sz="850" b="1" spc="100" kern="0" dirty="0">
+                <a:solidFill>
+                  <a:srgbClr val="1E2761"/>
+                </a:solidFill>
+              </a:rPr>
+              <a:t>EXTERNAL</a:t>
+            </a:r>
+            <a:endParaRPr lang="en-US" sz="850" dirty="0"/>
+          </a:p>
+        </p:txBody>
+      </p:sp>
+      <p:sp>
+        <p:nvSpPr>
+          <p:cNvPr id="8" name="Shape 6"/>
+          <p:cNvSpPr/>
+          <p:nvPr/>
+        </p:nvSpPr>
+        <p:spPr>
+          <a:xfrm>
+            <a:off x="566928" y="1755648"/>
+            <a:ext cx="1773936" cy="512064"/>
+          </a:xfrm>
+          <a:prstGeom prst="roundRect">
+            <a:avLst>
+              <a:gd name="adj" fmla="val 7143"/>
             </a:avLst>
           </a:prstGeom>
           <a:solidFill>
@@ -4351,97 +4414,58 @@
       </p:sp>
       <p:sp>
         <p:nvSpPr>
-          <p:cNvPr id="7" name="Text 5"/>
-          <p:cNvSpPr/>
-          <p:nvPr/>
-        </p:nvSpPr>
-        <p:spPr>
-          <a:xfrm>
-            <a:off x="868680" y="1645920"/>
-            <a:ext cx="3840480" cy="457200"/>
-          </a:xfrm>
-          <a:prstGeom prst="rect">
-            <a:avLst/>
-          </a:prstGeom>
-          <a:noFill/>
-          <a:ln/>
-        </p:spPr>
-        <p:txBody>
-          <a:bodyPr wrap="square" rtlCol="0" anchor="ctr"/>
-          <a:lstStyle/>
-          <a:p>
-            <a:pPr indent="0" marL="0">
-              <a:buNone/>
-            </a:pPr>
-            <a:r>
-              <a:rPr lang="en-US" sz="1250" b="1" dirty="0">
+          <p:cNvPr id="9" name="Text 7"/>
+          <p:cNvSpPr/>
+          <p:nvPr/>
+        </p:nvSpPr>
+        <p:spPr>
+          <a:xfrm>
+            <a:off x="621792" y="1755648"/>
+            <a:ext cx="1664208" cy="512064"/>
+          </a:xfrm>
+          <a:prstGeom prst="rect">
+            <a:avLst/>
+          </a:prstGeom>
+          <a:noFill/>
+          <a:ln/>
+        </p:spPr>
+        <p:txBody>
+          <a:bodyPr wrap="square" rtlCol="0" anchor="ctr"/>
+          <a:lstStyle/>
+          <a:p>
+            <a:pPr algn="ctr" indent="0" marL="0">
+              <a:buNone/>
+            </a:pPr>
+            <a:r>
+              <a:rPr lang="en-US" sz="880" dirty="0">
                 <a:solidFill>
                   <a:srgbClr val="FFFFFF"/>
                 </a:solidFill>
-                <a:latin typeface="Cambria" pitchFamily="34" charset="0"/>
-                <a:ea typeface="Cambria" pitchFamily="34" charset="-122"/>
-                <a:cs typeface="Cambria" pitchFamily="34" charset="-120"/>
-              </a:rPr>
-              <a:t>EDGE / FRONT-END SECURITY</a:t>
-            </a:r>
-            <a:endParaRPr lang="en-US" sz="1250" dirty="0"/>
-          </a:p>
-        </p:txBody>
-      </p:sp>
-      <p:sp>
-        <p:nvSpPr>
-          <p:cNvPr id="8" name="Text 6"/>
-          <p:cNvSpPr/>
-          <p:nvPr/>
-        </p:nvSpPr>
-        <p:spPr>
-          <a:xfrm>
-            <a:off x="4206240" y="1627632"/>
-            <a:ext cx="7132320" cy="402336"/>
-          </a:xfrm>
-          <a:prstGeom prst="rect">
-            <a:avLst/>
-          </a:prstGeom>
-          <a:noFill/>
-          <a:ln/>
-        </p:spPr>
-        <p:txBody>
-          <a:bodyPr wrap="square" rtlCol="0" anchor="ctr"/>
-          <a:lstStyle/>
-          <a:p>
-            <a:pPr indent="0" marL="0">
-              <a:buNone/>
-            </a:pPr>
-            <a:r>
-              <a:rPr lang="en-US" sz="1100" dirty="0">
-                <a:solidFill>
-                  <a:srgbClr val="CADCFC"/>
-                </a:solidFill>
-              </a:rPr>
-              <a:t>Amazon CloudFront (TLS 1.2+) + AWS WAF (managed rules — OWASP, known-bad-inputs, IP reputation, rate-limit) + Shield → API Gateway/ALB · Cognito (SAML→JWT, MFA at agency IdP) · PrivateLink to 311/CRM · knowledge base · scheduling · GIS</a:t>
-            </a:r>
-            <a:endParaRPr lang="en-US" sz="1100" dirty="0"/>
-          </a:p>
-        </p:txBody>
-      </p:sp>
-      <p:sp>
-        <p:nvSpPr>
-          <p:cNvPr id="9" name="Shape 7"/>
-          <p:cNvSpPr/>
-          <p:nvPr/>
-        </p:nvSpPr>
-        <p:spPr>
-          <a:xfrm>
-            <a:off x="640080" y="2103120"/>
-            <a:ext cx="10881360" cy="512064"/>
+              </a:rPr>
+              <a:t>Residents / agency staff</a:t>
+            </a:r>
+            <a:endParaRPr lang="en-US" sz="880" dirty="0"/>
+          </a:p>
+        </p:txBody>
+      </p:sp>
+      <p:sp>
+        <p:nvSpPr>
+          <p:cNvPr id="10" name="Shape 8"/>
+          <p:cNvSpPr/>
+          <p:nvPr/>
+        </p:nvSpPr>
+        <p:spPr>
+          <a:xfrm>
+            <a:off x="566928" y="2340864"/>
+            <a:ext cx="1773936" cy="512064"/>
           </a:xfrm>
           <a:prstGeom prst="roundRect">
             <a:avLst>
-              <a:gd name="adj" fmla="val 8929"/>
+              <a:gd name="adj" fmla="val 7143"/>
             </a:avLst>
           </a:prstGeom>
           <a:solidFill>
-            <a:srgbClr val="2A376E"/>
+            <a:srgbClr val="36406F"/>
           </a:solidFill>
           <a:ln/>
           <a:effectLst>
@@ -4455,76 +4479,37 @@
       </p:sp>
       <p:sp>
         <p:nvSpPr>
-          <p:cNvPr id="10" name="Text 8"/>
-          <p:cNvSpPr/>
-          <p:nvPr/>
-        </p:nvSpPr>
-        <p:spPr>
-          <a:xfrm>
-            <a:off x="868680" y="2176272"/>
-            <a:ext cx="3840480" cy="457200"/>
-          </a:xfrm>
-          <a:prstGeom prst="rect">
-            <a:avLst/>
-          </a:prstGeom>
-          <a:noFill/>
-          <a:ln/>
-        </p:spPr>
-        <p:txBody>
-          <a:bodyPr wrap="square" rtlCol="0" anchor="ctr"/>
-          <a:lstStyle/>
-          <a:p>
-            <a:pPr indent="0" marL="0">
-              <a:buNone/>
-            </a:pPr>
-            <a:r>
-              <a:rPr lang="en-US" sz="1250" b="1" dirty="0">
+          <p:cNvPr id="11" name="Text 9"/>
+          <p:cNvSpPr/>
+          <p:nvPr/>
+        </p:nvSpPr>
+        <p:spPr>
+          <a:xfrm>
+            <a:off x="621792" y="2340864"/>
+            <a:ext cx="1664208" cy="512064"/>
+          </a:xfrm>
+          <a:prstGeom prst="rect">
+            <a:avLst/>
+          </a:prstGeom>
+          <a:noFill/>
+          <a:ln/>
+        </p:spPr>
+        <p:txBody>
+          <a:bodyPr wrap="square" rtlCol="0" anchor="ctr"/>
+          <a:lstStyle/>
+          <a:p>
+            <a:pPr algn="ctr" indent="0" marL="0">
+              <a:buNone/>
+            </a:pPr>
+            <a:r>
+              <a:rPr lang="en-US" sz="880" dirty="0">
                 <a:solidFill>
                   <a:srgbClr val="FFFFFF"/>
                 </a:solidFill>
-                <a:latin typeface="Cambria" pitchFamily="34" charset="0"/>
-                <a:ea typeface="Cambria" pitchFamily="34" charset="-122"/>
-                <a:cs typeface="Cambria" pitchFamily="34" charset="-120"/>
-              </a:rPr>
-              <a:t>AGENT RUNTIME (private subnet)</a:t>
-            </a:r>
-            <a:endParaRPr lang="en-US" sz="1250" dirty="0"/>
-          </a:p>
-        </p:txBody>
-      </p:sp>
-      <p:sp>
-        <p:nvSpPr>
-          <p:cNvPr id="11" name="Text 9"/>
-          <p:cNvSpPr/>
-          <p:nvPr/>
-        </p:nvSpPr>
-        <p:spPr>
-          <a:xfrm>
-            <a:off x="4206240" y="2157984"/>
-            <a:ext cx="7132320" cy="402336"/>
-          </a:xfrm>
-          <a:prstGeom prst="rect">
-            <a:avLst/>
-          </a:prstGeom>
-          <a:noFill/>
-          <a:ln/>
-        </p:spPr>
-        <p:txBody>
-          <a:bodyPr wrap="square" rtlCol="0" anchor="ctr"/>
-          <a:lstStyle/>
-          <a:p>
-            <a:pPr indent="0" marL="0">
-              <a:buNone/>
-            </a:pPr>
-            <a:r>
-              <a:rPr lang="en-US" sz="1100" dirty="0">
-                <a:solidFill>
-                  <a:srgbClr val="CADCFC"/>
-                </a:solidFill>
-              </a:rPr>
-              <a:t>AWS Step Functions + Lambda (LangGraph agent) — waitForTaskToken human gate · or AgentCore Runtime (ARM64) · MCP authorization gateway (every tool call) · queue-driven autoscaling</a:t>
-            </a:r>
-            <a:endParaRPr lang="en-US" sz="1100" dirty="0"/>
+              </a:rPr>
+              <a:t>Agency IdP — SAML/OIDC · MFA</a:t>
+            </a:r>
+            <a:endParaRPr lang="en-US" sz="880" dirty="0"/>
           </a:p>
         </p:txBody>
       </p:sp>
@@ -4536,16 +4521,16 @@
         </p:nvSpPr>
         <p:spPr>
           <a:xfrm>
-            <a:off x="640080" y="2633472"/>
-            <a:ext cx="10881360" cy="512064"/>
+            <a:off x="566928" y="3108960"/>
+            <a:ext cx="1773936" cy="512064"/>
           </a:xfrm>
           <a:prstGeom prst="roundRect">
             <a:avLst>
-              <a:gd name="adj" fmla="val 8929"/>
+              <a:gd name="adj" fmla="val 7143"/>
             </a:avLst>
           </a:prstGeom>
           <a:solidFill>
-            <a:srgbClr val="1E2761"/>
+            <a:srgbClr val="4A5687"/>
           </a:solidFill>
           <a:ln/>
           <a:effectLst>
@@ -4565,91 +4550,52 @@
         </p:nvSpPr>
         <p:spPr>
           <a:xfrm>
-            <a:off x="868680" y="2706624"/>
-            <a:ext cx="3840480" cy="457200"/>
-          </a:xfrm>
-          <a:prstGeom prst="rect">
-            <a:avLst/>
-          </a:prstGeom>
-          <a:noFill/>
-          <a:ln/>
-        </p:spPr>
-        <p:txBody>
-          <a:bodyPr wrap="square" rtlCol="0" anchor="ctr"/>
-          <a:lstStyle/>
-          <a:p>
-            <a:pPr indent="0" marL="0">
-              <a:buNone/>
-            </a:pPr>
-            <a:r>
-              <a:rPr lang="en-US" sz="1250" b="1" dirty="0">
+            <a:off x="621792" y="3108960"/>
+            <a:ext cx="1664208" cy="512064"/>
+          </a:xfrm>
+          <a:prstGeom prst="rect">
+            <a:avLst/>
+          </a:prstGeom>
+          <a:noFill/>
+          <a:ln/>
+        </p:spPr>
+        <p:txBody>
+          <a:bodyPr wrap="square" rtlCol="0" anchor="ctr"/>
+          <a:lstStyle/>
+          <a:p>
+            <a:pPr algn="ctr" indent="0" marL="0">
+              <a:buNone/>
+            </a:pPr>
+            <a:r>
+              <a:rPr lang="en-US" sz="880" dirty="0">
                 <a:solidFill>
                   <a:srgbClr val="FFFFFF"/>
                 </a:solidFill>
-                <a:latin typeface="Cambria" pitchFamily="34" charset="0"/>
-                <a:ea typeface="Cambria" pitchFamily="34" charset="-122"/>
-                <a:cs typeface="Cambria" pitchFamily="34" charset="-120"/>
-              </a:rPr>
-              <a:t>MODEL LAYER (VPC endpoint)</a:t>
-            </a:r>
-            <a:endParaRPr lang="en-US" sz="1250" dirty="0"/>
-          </a:p>
-        </p:txBody>
-      </p:sp>
-      <p:sp>
-        <p:nvSpPr>
-          <p:cNvPr id="14" name="Text 12"/>
-          <p:cNvSpPr/>
-          <p:nvPr/>
-        </p:nvSpPr>
-        <p:spPr>
-          <a:xfrm>
-            <a:off x="4206240" y="2688336"/>
-            <a:ext cx="7132320" cy="402336"/>
-          </a:xfrm>
-          <a:prstGeom prst="rect">
-            <a:avLst/>
-          </a:prstGeom>
-          <a:noFill/>
-          <a:ln/>
-        </p:spPr>
-        <p:txBody>
-          <a:bodyPr wrap="square" rtlCol="0" anchor="ctr"/>
-          <a:lstStyle/>
-          <a:p>
-            <a:pPr indent="0" marL="0">
-              <a:buNone/>
-            </a:pPr>
-            <a:r>
-              <a:rPr lang="en-US" sz="1100" dirty="0">
-                <a:solidFill>
-                  <a:srgbClr val="CADCFC"/>
-                </a:solidFill>
-              </a:rPr>
-              <a:t>Amazon Bedrock — Claude Sonnet (draft) + Haiku (triage)  ·  Bedrock Guardrails — PII &amp; content filters (mandatory)</a:t>
-            </a:r>
-            <a:endParaRPr lang="en-US" sz="1100" dirty="0"/>
-          </a:p>
-        </p:txBody>
-      </p:sp>
-      <p:sp>
-        <p:nvSpPr>
-          <p:cNvPr id="15" name="Shape 13"/>
-          <p:cNvSpPr/>
-          <p:nvPr/>
-        </p:nvSpPr>
-        <p:spPr>
-          <a:xfrm>
-            <a:off x="640080" y="3163824"/>
-            <a:ext cx="10881360" cy="512064"/>
+              </a:rPr>
+              <a:t>Agency systems (on-prem)</a:t>
+            </a:r>
+            <a:endParaRPr lang="en-US" sz="880" dirty="0"/>
+          </a:p>
+        </p:txBody>
+      </p:sp>
+      <p:sp>
+        <p:nvSpPr>
+          <p:cNvPr id="14" name="Shape 12"/>
+          <p:cNvSpPr/>
+          <p:nvPr/>
+        </p:nvSpPr>
+        <p:spPr>
+          <a:xfrm>
+            <a:off x="566928" y="3694176"/>
+            <a:ext cx="1773936" cy="512064"/>
           </a:xfrm>
           <a:prstGeom prst="roundRect">
             <a:avLst>
-              <a:gd name="adj" fmla="val 8929"/>
+              <a:gd name="adj" fmla="val 7143"/>
             </a:avLst>
           </a:prstGeom>
           <a:solidFill>
-            <a:srgbClr val="2A376E"/>
+            <a:srgbClr val="4A5687"/>
           </a:solidFill>
           <a:ln/>
           <a:effectLst>
@@ -4663,14 +4609,113 @@
       </p:sp>
       <p:sp>
         <p:nvSpPr>
+          <p:cNvPr id="15" name="Text 13"/>
+          <p:cNvSpPr/>
+          <p:nvPr/>
+        </p:nvSpPr>
+        <p:spPr>
+          <a:xfrm>
+            <a:off x="621792" y="3694176"/>
+            <a:ext cx="1664208" cy="512064"/>
+          </a:xfrm>
+          <a:prstGeom prst="rect">
+            <a:avLst/>
+          </a:prstGeom>
+          <a:noFill/>
+          <a:ln/>
+        </p:spPr>
+        <p:txBody>
+          <a:bodyPr wrap="square" rtlCol="0" anchor="ctr"/>
+          <a:lstStyle/>
+          <a:p>
+            <a:pPr algn="ctr" indent="0" marL="0">
+              <a:buNone/>
+            </a:pPr>
+            <a:r>
+              <a:rPr lang="en-US" sz="880" dirty="0">
+                <a:solidFill>
+                  <a:srgbClr val="FFFFFF"/>
+                </a:solidFill>
+              </a:rPr>
+              <a:t>External data sources</a:t>
+            </a:r>
+            <a:endParaRPr lang="en-US" sz="880" dirty="0"/>
+          </a:p>
+        </p:txBody>
+      </p:sp>
+      <p:sp>
+        <p:nvSpPr>
           <p:cNvPr id="16" name="Text 14"/>
           <p:cNvSpPr/>
           <p:nvPr/>
         </p:nvSpPr>
         <p:spPr>
           <a:xfrm>
-            <a:off x="868680" y="3236976"/>
-            <a:ext cx="3840480" cy="457200"/>
+            <a:off x="566928" y="4334256"/>
+            <a:ext cx="1773936" cy="274320"/>
+          </a:xfrm>
+          <a:prstGeom prst="rect">
+            <a:avLst/>
+          </a:prstGeom>
+          <a:noFill/>
+          <a:ln/>
+        </p:spPr>
+        <p:txBody>
+          <a:bodyPr wrap="square" rtlCol="0" anchor="ctr"/>
+          <a:lstStyle/>
+          <a:p>
+            <a:pPr algn="ctr" indent="0" marL="0">
+              <a:buNone/>
+            </a:pPr>
+            <a:r>
+              <a:rPr lang="en-US" sz="700" i="1" dirty="0">
+                <a:solidFill>
+                  <a:srgbClr val="5B6488"/>
+                </a:solidFill>
+              </a:rPr>
+              <a:t>PrivateLink / Direct Connect</a:t>
+            </a:r>
+            <a:endParaRPr lang="en-US" sz="700" dirty="0"/>
+          </a:p>
+        </p:txBody>
+      </p:sp>
+      <p:sp>
+        <p:nvSpPr>
+          <p:cNvPr id="17" name="Shape 15"/>
+          <p:cNvSpPr/>
+          <p:nvPr/>
+        </p:nvSpPr>
+        <p:spPr>
+          <a:xfrm>
+            <a:off x="2615184" y="1444752"/>
+            <a:ext cx="9116568" cy="3310128"/>
+          </a:xfrm>
+          <a:prstGeom prst="roundRect">
+            <a:avLst>
+              <a:gd name="adj" fmla="val 1381"/>
+            </a:avLst>
+          </a:prstGeom>
+          <a:solidFill>
+            <a:srgbClr val="F4F7FE"/>
+          </a:solidFill>
+          <a:ln w="12700">
+            <a:solidFill>
+              <a:srgbClr val="C2D0EC"/>
+            </a:solidFill>
+            <a:prstDash val="solid"/>
+          </a:ln>
+        </p:spPr>
+      </p:sp>
+      <p:sp>
+        <p:nvSpPr>
+          <p:cNvPr id="18" name="Text 16"/>
+          <p:cNvSpPr/>
+          <p:nvPr/>
+        </p:nvSpPr>
+        <p:spPr>
+          <a:xfrm>
+            <a:off x="2724912" y="1499616"/>
+            <a:ext cx="8897112" cy="219456"/>
           </a:xfrm>
           <a:prstGeom prst="rect">
             <a:avLst/>
@@ -4686,51 +4731,199 @@
               <a:buNone/>
             </a:pPr>
             <a:r>
-              <a:rPr lang="en-US" sz="1250" b="1" dirty="0">
+              <a:rPr lang="en-US" sz="850" b="1" spc="100" kern="0" dirty="0">
+                <a:solidFill>
+                  <a:srgbClr val="1E2761"/>
+                </a:solidFill>
+              </a:rPr>
+              <a:t>AWS CLOUD — per-customer VPC / dedicated account</a:t>
+            </a:r>
+            <a:endParaRPr lang="en-US" sz="850" dirty="0"/>
+          </a:p>
+        </p:txBody>
+      </p:sp>
+      <p:sp>
+        <p:nvSpPr>
+          <p:cNvPr id="19" name="Shape 17"/>
+          <p:cNvSpPr/>
+          <p:nvPr/>
+        </p:nvSpPr>
+        <p:spPr>
+          <a:xfrm>
+            <a:off x="2743200" y="1773936"/>
+            <a:ext cx="2505456" cy="2852928"/>
+          </a:xfrm>
+          <a:prstGeom prst="roundRect">
+            <a:avLst>
+              <a:gd name="adj" fmla="val 1825"/>
+            </a:avLst>
+          </a:prstGeom>
+          <a:solidFill>
+            <a:srgbClr val="F4F7FE"/>
+          </a:solidFill>
+          <a:ln w="12700">
+            <a:solidFill>
+              <a:srgbClr val="C2D0EC"/>
+            </a:solidFill>
+            <a:prstDash val="solid"/>
+          </a:ln>
+        </p:spPr>
+      </p:sp>
+      <p:sp>
+        <p:nvSpPr>
+          <p:cNvPr id="20" name="Text 18"/>
+          <p:cNvSpPr/>
+          <p:nvPr/>
+        </p:nvSpPr>
+        <p:spPr>
+          <a:xfrm>
+            <a:off x="2852928" y="1828800"/>
+            <a:ext cx="2286000" cy="219456"/>
+          </a:xfrm>
+          <a:prstGeom prst="rect">
+            <a:avLst/>
+          </a:prstGeom>
+          <a:noFill/>
+          <a:ln/>
+        </p:spPr>
+        <p:txBody>
+          <a:bodyPr wrap="square" rtlCol="0" anchor="ctr"/>
+          <a:lstStyle/>
+          <a:p>
+            <a:pPr indent="0" marL="0">
+              <a:buNone/>
+            </a:pPr>
+            <a:r>
+              <a:rPr lang="en-US" sz="850" b="1" spc="100" kern="0" dirty="0">
+                <a:solidFill>
+                  <a:srgbClr val="1E2761"/>
+                </a:solidFill>
+              </a:rPr>
+              <a:t>EDGE / PUBLIC SUBNET</a:t>
+            </a:r>
+            <a:endParaRPr lang="en-US" sz="850" dirty="0"/>
+          </a:p>
+        </p:txBody>
+      </p:sp>
+      <p:sp>
+        <p:nvSpPr>
+          <p:cNvPr id="21" name="Shape 19"/>
+          <p:cNvSpPr/>
+          <p:nvPr/>
+        </p:nvSpPr>
+        <p:spPr>
+          <a:xfrm>
+            <a:off x="2852928" y="2066544"/>
+            <a:ext cx="2286000" cy="512064"/>
+          </a:xfrm>
+          <a:prstGeom prst="roundRect">
+            <a:avLst>
+              <a:gd name="adj" fmla="val 7143"/>
+            </a:avLst>
+          </a:prstGeom>
+          <a:solidFill>
+            <a:srgbClr val="1E2761"/>
+          </a:solidFill>
+          <a:ln/>
+          <a:effectLst>
+            <a:outerShdw sx="100000" sy="100000" kx="0" ky="0" algn="bl" rotWithShape="0" blurRad="88900" dist="38100" dir="5400000">
+              <a:srgbClr val="000000">
+                <a:alpha val="15000"/>
+              </a:srgbClr>
+            </a:outerShdw>
+          </a:effectLst>
+        </p:spPr>
+      </p:sp>
+      <p:sp>
+        <p:nvSpPr>
+          <p:cNvPr id="22" name="Text 20"/>
+          <p:cNvSpPr/>
+          <p:nvPr/>
+        </p:nvSpPr>
+        <p:spPr>
+          <a:xfrm>
+            <a:off x="2907792" y="2066544"/>
+            <a:ext cx="2176272" cy="512064"/>
+          </a:xfrm>
+          <a:prstGeom prst="rect">
+            <a:avLst/>
+          </a:prstGeom>
+          <a:noFill/>
+          <a:ln/>
+        </p:spPr>
+        <p:txBody>
+          <a:bodyPr wrap="square" rtlCol="0" anchor="ctr"/>
+          <a:lstStyle/>
+          <a:p>
+            <a:pPr algn="ctr" indent="0" marL="0">
+              <a:buNone/>
+            </a:pPr>
+            <a:r>
+              <a:rPr lang="en-US" sz="880" dirty="0">
                 <a:solidFill>
                   <a:srgbClr val="FFFFFF"/>
+                </a:solidFill>
+              </a:rPr>
+              <a:t>CloudFront + WAF + Shield (TLS 1.2+)</a:t>
+            </a:r>
+            <a:endParaRPr lang="en-US" sz="880" dirty="0"/>
+          </a:p>
+        </p:txBody>
+      </p:sp>
+      <p:sp>
+        <p:nvSpPr>
+          <p:cNvPr id="23" name="Shape 21"/>
+          <p:cNvSpPr/>
+          <p:nvPr/>
+        </p:nvSpPr>
+        <p:spPr>
+          <a:xfrm>
+            <a:off x="2761488" y="1993392"/>
+            <a:ext cx="274320" cy="274320"/>
+          </a:xfrm>
+          <a:prstGeom prst="ellipse">
+            <a:avLst/>
+          </a:prstGeom>
+          <a:solidFill>
+            <a:srgbClr val="E0A53B"/>
+          </a:solidFill>
+          <a:ln/>
+        </p:spPr>
+      </p:sp>
+      <p:sp>
+        <p:nvSpPr>
+          <p:cNvPr id="24" name="Text 22"/>
+          <p:cNvSpPr/>
+          <p:nvPr/>
+        </p:nvSpPr>
+        <p:spPr>
+          <a:xfrm>
+            <a:off x="2761488" y="1993392"/>
+            <a:ext cx="274320" cy="274320"/>
+          </a:xfrm>
+          <a:prstGeom prst="rect">
+            <a:avLst/>
+          </a:prstGeom>
+          <a:noFill/>
+          <a:ln/>
+        </p:spPr>
+        <p:txBody>
+          <a:bodyPr wrap="square" rtlCol="0" anchor="ctr"/>
+          <a:lstStyle/>
+          <a:p>
+            <a:pPr algn="ctr" indent="0" marL="0">
+              <a:buNone/>
+            </a:pPr>
+            <a:r>
+              <a:rPr lang="en-US" sz="1100" b="1" dirty="0">
+                <a:solidFill>
+                  <a:srgbClr val="3A2A05"/>
                 </a:solidFill>
                 <a:latin typeface="Cambria" pitchFamily="34" charset="0"/>
                 <a:ea typeface="Cambria" pitchFamily="34" charset="-122"/>
                 <a:cs typeface="Cambria" pitchFamily="34" charset="-120"/>
               </a:rPr>
-              <a:t>DATA TIER (KMS CMK per data class)</a:t>
-            </a:r>
-            <a:endParaRPr lang="en-US" sz="1250" dirty="0"/>
-          </a:p>
-        </p:txBody>
-      </p:sp>
-      <p:sp>
-        <p:nvSpPr>
-          <p:cNvPr id="17" name="Text 15"/>
-          <p:cNvSpPr/>
-          <p:nvPr/>
-        </p:nvSpPr>
-        <p:spPr>
-          <a:xfrm>
-            <a:off x="4206240" y="3218688"/>
-            <a:ext cx="7132320" cy="402336"/>
-          </a:xfrm>
-          <a:prstGeom prst="rect">
-            <a:avLst/>
-          </a:prstGeom>
-          <a:noFill/>
-          <a:ln/>
-        </p:spPr>
-        <p:txBody>
-          <a:bodyPr wrap="square" rtlCol="0" anchor="ctr"/>
-          <a:lstStyle/>
-          <a:p>
-            <a:pPr indent="0" marL="0">
-              <a:buNone/>
-            </a:pPr>
-            <a:r>
-              <a:rPr lang="en-US" sz="1100" dirty="0">
-                <a:solidFill>
-                  <a:srgbClr val="CADCFC"/>
-                </a:solidFill>
-              </a:rPr>
-              <a:t>DynamoDB — case state + append-only audit  ·  S3 Object Lock (WORM) — finalized records</a:t>
+              <a:t>2</a:t>
             </a:r>
             <a:endParaRPr lang="en-US" sz="1100" dirty="0"/>
           </a:p>
@@ -4738,21 +4931,1273 @@
       </p:sp>
       <p:sp>
         <p:nvSpPr>
-          <p:cNvPr id="18" name="Shape 16"/>
-          <p:cNvSpPr/>
-          <p:nvPr/>
-        </p:nvSpPr>
-        <p:spPr>
-          <a:xfrm>
-            <a:off x="640080" y="3767328"/>
-            <a:ext cx="10881360" cy="420624"/>
+          <p:cNvPr id="25" name="Shape 23"/>
+          <p:cNvSpPr/>
+          <p:nvPr/>
+        </p:nvSpPr>
+        <p:spPr>
+          <a:xfrm>
+            <a:off x="2852928" y="2724912"/>
+            <a:ext cx="2286000" cy="512064"/>
           </a:xfrm>
           <a:prstGeom prst="roundRect">
             <a:avLst>
-              <a:gd name="adj" fmla="val 10870"/>
+              <a:gd name="adj" fmla="val 7143"/>
             </a:avLst>
           </a:prstGeom>
           <a:solidFill>
+            <a:srgbClr val="2A376E"/>
+          </a:solidFill>
+          <a:ln/>
+          <a:effectLst>
+            <a:outerShdw sx="100000" sy="100000" kx="0" ky="0" algn="bl" rotWithShape="0" blurRad="88900" dist="38100" dir="5400000">
+              <a:srgbClr val="000000">
+                <a:alpha val="15000"/>
+              </a:srgbClr>
+            </a:outerShdw>
+          </a:effectLst>
+        </p:spPr>
+      </p:sp>
+      <p:sp>
+        <p:nvSpPr>
+          <p:cNvPr id="26" name="Text 24"/>
+          <p:cNvSpPr/>
+          <p:nvPr/>
+        </p:nvSpPr>
+        <p:spPr>
+          <a:xfrm>
+            <a:off x="2907792" y="2724912"/>
+            <a:ext cx="2176272" cy="512064"/>
+          </a:xfrm>
+          <a:prstGeom prst="rect">
+            <a:avLst/>
+          </a:prstGeom>
+          <a:noFill/>
+          <a:ln/>
+        </p:spPr>
+        <p:txBody>
+          <a:bodyPr wrap="square" rtlCol="0" anchor="ctr"/>
+          <a:lstStyle/>
+          <a:p>
+            <a:pPr algn="ctr" indent="0" marL="0">
+              <a:buNone/>
+            </a:pPr>
+            <a:r>
+              <a:rPr lang="en-US" sz="880" dirty="0">
+                <a:solidFill>
+                  <a:srgbClr val="FFFFFF"/>
+                </a:solidFill>
+              </a:rPr>
+              <a:t>API Gateway / ALB</a:t>
+            </a:r>
+            <a:endParaRPr lang="en-US" sz="880" dirty="0"/>
+          </a:p>
+        </p:txBody>
+      </p:sp>
+      <p:sp>
+        <p:nvSpPr>
+          <p:cNvPr id="27" name="Shape 25"/>
+          <p:cNvSpPr/>
+          <p:nvPr/>
+        </p:nvSpPr>
+        <p:spPr>
+          <a:xfrm>
+            <a:off x="2852928" y="3383280"/>
+            <a:ext cx="2286000" cy="512064"/>
+          </a:xfrm>
+          <a:prstGeom prst="roundRect">
+            <a:avLst>
+              <a:gd name="adj" fmla="val 7143"/>
+            </a:avLst>
+          </a:prstGeom>
+          <a:solidFill>
+            <a:srgbClr val="2A376E"/>
+          </a:solidFill>
+          <a:ln/>
+          <a:effectLst>
+            <a:outerShdw sx="100000" sy="100000" kx="0" ky="0" algn="bl" rotWithShape="0" blurRad="88900" dist="38100" dir="5400000">
+              <a:srgbClr val="000000">
+                <a:alpha val="15000"/>
+              </a:srgbClr>
+            </a:outerShdw>
+          </a:effectLst>
+        </p:spPr>
+      </p:sp>
+      <p:sp>
+        <p:nvSpPr>
+          <p:cNvPr id="28" name="Text 26"/>
+          <p:cNvSpPr/>
+          <p:nvPr/>
+        </p:nvSpPr>
+        <p:spPr>
+          <a:xfrm>
+            <a:off x="2907792" y="3383280"/>
+            <a:ext cx="2176272" cy="512064"/>
+          </a:xfrm>
+          <a:prstGeom prst="rect">
+            <a:avLst/>
+          </a:prstGeom>
+          <a:noFill/>
+          <a:ln/>
+        </p:spPr>
+        <p:txBody>
+          <a:bodyPr wrap="square" rtlCol="0" anchor="ctr"/>
+          <a:lstStyle/>
+          <a:p>
+            <a:pPr algn="ctr" indent="0" marL="0">
+              <a:buNone/>
+            </a:pPr>
+            <a:r>
+              <a:rPr lang="en-US" sz="880" dirty="0">
+                <a:solidFill>
+                  <a:srgbClr val="FFFFFF"/>
+                </a:solidFill>
+              </a:rPr>
+              <a:t>Amazon Cognito — SAML → JWT</a:t>
+            </a:r>
+            <a:endParaRPr lang="en-US" sz="880" dirty="0"/>
+          </a:p>
+        </p:txBody>
+      </p:sp>
+      <p:sp>
+        <p:nvSpPr>
+          <p:cNvPr id="29" name="Shape 27"/>
+          <p:cNvSpPr/>
+          <p:nvPr/>
+        </p:nvSpPr>
+        <p:spPr>
+          <a:xfrm>
+            <a:off x="2761488" y="3310128"/>
+            <a:ext cx="274320" cy="274320"/>
+          </a:xfrm>
+          <a:prstGeom prst="ellipse">
+            <a:avLst/>
+          </a:prstGeom>
+          <a:solidFill>
+            <a:srgbClr val="E0A53B"/>
+          </a:solidFill>
+          <a:ln/>
+        </p:spPr>
+      </p:sp>
+      <p:sp>
+        <p:nvSpPr>
+          <p:cNvPr id="30" name="Text 28"/>
+          <p:cNvSpPr/>
+          <p:nvPr/>
+        </p:nvSpPr>
+        <p:spPr>
+          <a:xfrm>
+            <a:off x="2761488" y="3310128"/>
+            <a:ext cx="274320" cy="274320"/>
+          </a:xfrm>
+          <a:prstGeom prst="rect">
+            <a:avLst/>
+          </a:prstGeom>
+          <a:noFill/>
+          <a:ln/>
+        </p:spPr>
+        <p:txBody>
+          <a:bodyPr wrap="square" rtlCol="0" anchor="ctr"/>
+          <a:lstStyle/>
+          <a:p>
+            <a:pPr algn="ctr" indent="0" marL="0">
+              <a:buNone/>
+            </a:pPr>
+            <a:r>
+              <a:rPr lang="en-US" sz="1100" b="1" dirty="0">
+                <a:solidFill>
+                  <a:srgbClr val="3A2A05"/>
+                </a:solidFill>
+                <a:latin typeface="Cambria" pitchFamily="34" charset="0"/>
+                <a:ea typeface="Cambria" pitchFamily="34" charset="-122"/>
+                <a:cs typeface="Cambria" pitchFamily="34" charset="-120"/>
+              </a:rPr>
+              <a:t>1</a:t>
+            </a:r>
+            <a:endParaRPr lang="en-US" sz="1100" dirty="0"/>
+          </a:p>
+        </p:txBody>
+      </p:sp>
+      <p:sp>
+        <p:nvSpPr>
+          <p:cNvPr id="31" name="Shape 29"/>
+          <p:cNvSpPr/>
+          <p:nvPr/>
+        </p:nvSpPr>
+        <p:spPr>
+          <a:xfrm>
+            <a:off x="5358384" y="1773936"/>
+            <a:ext cx="2505456" cy="2852928"/>
+          </a:xfrm>
+          <a:prstGeom prst="roundRect">
+            <a:avLst>
+              <a:gd name="adj" fmla="val 1825"/>
+            </a:avLst>
+          </a:prstGeom>
+          <a:solidFill>
+            <a:srgbClr val="F4F7FE"/>
+          </a:solidFill>
+          <a:ln w="12700">
+            <a:solidFill>
+              <a:srgbClr val="C2D0EC"/>
+            </a:solidFill>
+            <a:prstDash val="solid"/>
+          </a:ln>
+        </p:spPr>
+      </p:sp>
+      <p:sp>
+        <p:nvSpPr>
+          <p:cNvPr id="32" name="Text 30"/>
+          <p:cNvSpPr/>
+          <p:nvPr/>
+        </p:nvSpPr>
+        <p:spPr>
+          <a:xfrm>
+            <a:off x="5468112" y="1828800"/>
+            <a:ext cx="2286000" cy="219456"/>
+          </a:xfrm>
+          <a:prstGeom prst="rect">
+            <a:avLst/>
+          </a:prstGeom>
+          <a:noFill/>
+          <a:ln/>
+        </p:spPr>
+        <p:txBody>
+          <a:bodyPr wrap="square" rtlCol="0" anchor="ctr"/>
+          <a:lstStyle/>
+          <a:p>
+            <a:pPr indent="0" marL="0">
+              <a:buNone/>
+            </a:pPr>
+            <a:r>
+              <a:rPr lang="en-US" sz="850" b="1" spc="100" kern="0" dirty="0">
+                <a:solidFill>
+                  <a:srgbClr val="1E2761"/>
+                </a:solidFill>
+              </a:rPr>
+              <a:t>PRIVATE SUBNET — COMPUTE</a:t>
+            </a:r>
+            <a:endParaRPr lang="en-US" sz="850" dirty="0"/>
+          </a:p>
+        </p:txBody>
+      </p:sp>
+      <p:sp>
+        <p:nvSpPr>
+          <p:cNvPr id="33" name="Shape 31"/>
+          <p:cNvSpPr/>
+          <p:nvPr/>
+        </p:nvSpPr>
+        <p:spPr>
+          <a:xfrm>
+            <a:off x="5468112" y="2066544"/>
+            <a:ext cx="2286000" cy="512064"/>
+          </a:xfrm>
+          <a:prstGeom prst="roundRect">
+            <a:avLst>
+              <a:gd name="adj" fmla="val 7143"/>
+            </a:avLst>
+          </a:prstGeom>
+          <a:solidFill>
+            <a:srgbClr val="2A376E"/>
+          </a:solidFill>
+          <a:ln/>
+          <a:effectLst>
+            <a:outerShdw sx="100000" sy="100000" kx="0" ky="0" algn="bl" rotWithShape="0" blurRad="88900" dist="38100" dir="5400000">
+              <a:srgbClr val="000000">
+                <a:alpha val="15000"/>
+              </a:srgbClr>
+            </a:outerShdw>
+          </a:effectLst>
+        </p:spPr>
+      </p:sp>
+      <p:sp>
+        <p:nvSpPr>
+          <p:cNvPr id="34" name="Text 32"/>
+          <p:cNvSpPr/>
+          <p:nvPr/>
+        </p:nvSpPr>
+        <p:spPr>
+          <a:xfrm>
+            <a:off x="5522976" y="2066544"/>
+            <a:ext cx="2176272" cy="512064"/>
+          </a:xfrm>
+          <a:prstGeom prst="rect">
+            <a:avLst/>
+          </a:prstGeom>
+          <a:noFill/>
+          <a:ln/>
+        </p:spPr>
+        <p:txBody>
+          <a:bodyPr wrap="square" rtlCol="0" anchor="ctr"/>
+          <a:lstStyle/>
+          <a:p>
+            <a:pPr algn="ctr" indent="0" marL="0">
+              <a:buNone/>
+            </a:pPr>
+            <a:r>
+              <a:rPr lang="en-US" sz="880" dirty="0">
+                <a:solidFill>
+                  <a:srgbClr val="FFFFFF"/>
+                </a:solidFill>
+              </a:rPr>
+              <a:t>Agent runtime — Step Functions + Lambda</a:t>
+            </a:r>
+            <a:endParaRPr lang="en-US" sz="880" dirty="0"/>
+          </a:p>
+        </p:txBody>
+      </p:sp>
+      <p:sp>
+        <p:nvSpPr>
+          <p:cNvPr id="35" name="Shape 33"/>
+          <p:cNvSpPr/>
+          <p:nvPr/>
+        </p:nvSpPr>
+        <p:spPr>
+          <a:xfrm>
+            <a:off x="5376672" y="1993392"/>
+            <a:ext cx="274320" cy="274320"/>
+          </a:xfrm>
+          <a:prstGeom prst="ellipse">
+            <a:avLst/>
+          </a:prstGeom>
+          <a:solidFill>
+            <a:srgbClr val="E0A53B"/>
+          </a:solidFill>
+          <a:ln/>
+        </p:spPr>
+      </p:sp>
+      <p:sp>
+        <p:nvSpPr>
+          <p:cNvPr id="36" name="Text 34"/>
+          <p:cNvSpPr/>
+          <p:nvPr/>
+        </p:nvSpPr>
+        <p:spPr>
+          <a:xfrm>
+            <a:off x="5376672" y="1993392"/>
+            <a:ext cx="274320" cy="274320"/>
+          </a:xfrm>
+          <a:prstGeom prst="rect">
+            <a:avLst/>
+          </a:prstGeom>
+          <a:noFill/>
+          <a:ln/>
+        </p:spPr>
+        <p:txBody>
+          <a:bodyPr wrap="square" rtlCol="0" anchor="ctr"/>
+          <a:lstStyle/>
+          <a:p>
+            <a:pPr algn="ctr" indent="0" marL="0">
+              <a:buNone/>
+            </a:pPr>
+            <a:r>
+              <a:rPr lang="en-US" sz="1100" b="1" dirty="0">
+                <a:solidFill>
+                  <a:srgbClr val="3A2A05"/>
+                </a:solidFill>
+                <a:latin typeface="Cambria" pitchFamily="34" charset="0"/>
+                <a:ea typeface="Cambria" pitchFamily="34" charset="-122"/>
+                <a:cs typeface="Cambria" pitchFamily="34" charset="-120"/>
+              </a:rPr>
+              <a:t>3</a:t>
+            </a:r>
+            <a:endParaRPr lang="en-US" sz="1100" dirty="0"/>
+          </a:p>
+        </p:txBody>
+      </p:sp>
+      <p:sp>
+        <p:nvSpPr>
+          <p:cNvPr id="37" name="Shape 35"/>
+          <p:cNvSpPr/>
+          <p:nvPr/>
+        </p:nvSpPr>
+        <p:spPr>
+          <a:xfrm>
+            <a:off x="5468112" y="2724912"/>
+            <a:ext cx="2286000" cy="512064"/>
+          </a:xfrm>
+          <a:prstGeom prst="roundRect">
+            <a:avLst>
+              <a:gd name="adj" fmla="val 7143"/>
+            </a:avLst>
+          </a:prstGeom>
+          <a:solidFill>
+            <a:srgbClr val="1E2761"/>
+          </a:solidFill>
+          <a:ln/>
+          <a:effectLst>
+            <a:outerShdw sx="100000" sy="100000" kx="0" ky="0" algn="bl" rotWithShape="0" blurRad="88900" dist="38100" dir="5400000">
+              <a:srgbClr val="000000">
+                <a:alpha val="15000"/>
+              </a:srgbClr>
+            </a:outerShdw>
+          </a:effectLst>
+        </p:spPr>
+      </p:sp>
+      <p:sp>
+        <p:nvSpPr>
+          <p:cNvPr id="38" name="Text 36"/>
+          <p:cNvSpPr/>
+          <p:nvPr/>
+        </p:nvSpPr>
+        <p:spPr>
+          <a:xfrm>
+            <a:off x="5522976" y="2724912"/>
+            <a:ext cx="2176272" cy="512064"/>
+          </a:xfrm>
+          <a:prstGeom prst="rect">
+            <a:avLst/>
+          </a:prstGeom>
+          <a:noFill/>
+          <a:ln/>
+        </p:spPr>
+        <p:txBody>
+          <a:bodyPr wrap="square" rtlCol="0" anchor="ctr"/>
+          <a:lstStyle/>
+          <a:p>
+            <a:pPr algn="ctr" indent="0" marL="0">
+              <a:buNone/>
+            </a:pPr>
+            <a:r>
+              <a:rPr lang="en-US" sz="880" dirty="0">
+                <a:solidFill>
+                  <a:srgbClr val="FFFFFF"/>
+                </a:solidFill>
+              </a:rPr>
+              <a:t>MCP authorization gateway</a:t>
+            </a:r>
+            <a:endParaRPr lang="en-US" sz="880" dirty="0"/>
+          </a:p>
+        </p:txBody>
+      </p:sp>
+      <p:sp>
+        <p:nvSpPr>
+          <p:cNvPr id="39" name="Shape 37"/>
+          <p:cNvSpPr/>
+          <p:nvPr/>
+        </p:nvSpPr>
+        <p:spPr>
+          <a:xfrm>
+            <a:off x="5376672" y="2651760"/>
+            <a:ext cx="274320" cy="274320"/>
+          </a:xfrm>
+          <a:prstGeom prst="ellipse">
+            <a:avLst/>
+          </a:prstGeom>
+          <a:solidFill>
+            <a:srgbClr val="E0A53B"/>
+          </a:solidFill>
+          <a:ln/>
+        </p:spPr>
+      </p:sp>
+      <p:sp>
+        <p:nvSpPr>
+          <p:cNvPr id="40" name="Text 38"/>
+          <p:cNvSpPr/>
+          <p:nvPr/>
+        </p:nvSpPr>
+        <p:spPr>
+          <a:xfrm>
+            <a:off x="5376672" y="2651760"/>
+            <a:ext cx="274320" cy="274320"/>
+          </a:xfrm>
+          <a:prstGeom prst="rect">
+            <a:avLst/>
+          </a:prstGeom>
+          <a:noFill/>
+          <a:ln/>
+        </p:spPr>
+        <p:txBody>
+          <a:bodyPr wrap="square" rtlCol="0" anchor="ctr"/>
+          <a:lstStyle/>
+          <a:p>
+            <a:pPr algn="ctr" indent="0" marL="0">
+              <a:buNone/>
+            </a:pPr>
+            <a:r>
+              <a:rPr lang="en-US" sz="1100" b="1" dirty="0">
+                <a:solidFill>
+                  <a:srgbClr val="3A2A05"/>
+                </a:solidFill>
+                <a:latin typeface="Cambria" pitchFamily="34" charset="0"/>
+                <a:ea typeface="Cambria" pitchFamily="34" charset="-122"/>
+                <a:cs typeface="Cambria" pitchFamily="34" charset="-120"/>
+              </a:rPr>
+              <a:t>4</a:t>
+            </a:r>
+            <a:endParaRPr lang="en-US" sz="1100" dirty="0"/>
+          </a:p>
+        </p:txBody>
+      </p:sp>
+      <p:sp>
+        <p:nvSpPr>
+          <p:cNvPr id="41" name="Shape 39"/>
+          <p:cNvSpPr/>
+          <p:nvPr/>
+        </p:nvSpPr>
+        <p:spPr>
+          <a:xfrm>
+            <a:off x="5468112" y="3383280"/>
+            <a:ext cx="2286000" cy="512064"/>
+          </a:xfrm>
+          <a:prstGeom prst="roundRect">
+            <a:avLst>
+              <a:gd name="adj" fmla="val 7143"/>
+            </a:avLst>
+          </a:prstGeom>
+          <a:solidFill>
+            <a:srgbClr val="2A376E"/>
+          </a:solidFill>
+          <a:ln/>
+          <a:effectLst>
+            <a:outerShdw sx="100000" sy="100000" kx="0" ky="0" algn="bl" rotWithShape="0" blurRad="88900" dist="38100" dir="5400000">
+              <a:srgbClr val="000000">
+                <a:alpha val="15000"/>
+              </a:srgbClr>
+            </a:outerShdw>
+          </a:effectLst>
+        </p:spPr>
+      </p:sp>
+      <p:sp>
+        <p:nvSpPr>
+          <p:cNvPr id="42" name="Text 40"/>
+          <p:cNvSpPr/>
+          <p:nvPr/>
+        </p:nvSpPr>
+        <p:spPr>
+          <a:xfrm>
+            <a:off x="5522976" y="3383280"/>
+            <a:ext cx="2176272" cy="512064"/>
+          </a:xfrm>
+          <a:prstGeom prst="rect">
+            <a:avLst/>
+          </a:prstGeom>
+          <a:noFill/>
+          <a:ln/>
+        </p:spPr>
+        <p:txBody>
+          <a:bodyPr wrap="square" rtlCol="0" anchor="ctr"/>
+          <a:lstStyle/>
+          <a:p>
+            <a:pPr algn="ctr" indent="0" marL="0">
+              <a:buNone/>
+            </a:pPr>
+            <a:r>
+              <a:rPr lang="en-US" sz="880" dirty="0">
+                <a:solidFill>
+                  <a:srgbClr val="FFFFFF"/>
+                </a:solidFill>
+              </a:rPr>
+              <a:t>SQS queue + DLQ · HITL gate</a:t>
+            </a:r>
+            <a:endParaRPr lang="en-US" sz="880" dirty="0"/>
+          </a:p>
+        </p:txBody>
+      </p:sp>
+      <p:sp>
+        <p:nvSpPr>
+          <p:cNvPr id="43" name="Shape 41"/>
+          <p:cNvSpPr/>
+          <p:nvPr/>
+        </p:nvSpPr>
+        <p:spPr>
+          <a:xfrm>
+            <a:off x="5376672" y="3310128"/>
+            <a:ext cx="274320" cy="274320"/>
+          </a:xfrm>
+          <a:prstGeom prst="ellipse">
+            <a:avLst/>
+          </a:prstGeom>
+          <a:solidFill>
+            <a:srgbClr val="E0A53B"/>
+          </a:solidFill>
+          <a:ln/>
+        </p:spPr>
+      </p:sp>
+      <p:sp>
+        <p:nvSpPr>
+          <p:cNvPr id="44" name="Text 42"/>
+          <p:cNvSpPr/>
+          <p:nvPr/>
+        </p:nvSpPr>
+        <p:spPr>
+          <a:xfrm>
+            <a:off x="5376672" y="3310128"/>
+            <a:ext cx="274320" cy="274320"/>
+          </a:xfrm>
+          <a:prstGeom prst="rect">
+            <a:avLst/>
+          </a:prstGeom>
+          <a:noFill/>
+          <a:ln/>
+        </p:spPr>
+        <p:txBody>
+          <a:bodyPr wrap="square" rtlCol="0" anchor="ctr"/>
+          <a:lstStyle/>
+          <a:p>
+            <a:pPr algn="ctr" indent="0" marL="0">
+              <a:buNone/>
+            </a:pPr>
+            <a:r>
+              <a:rPr lang="en-US" sz="1100" b="1" dirty="0">
+                <a:solidFill>
+                  <a:srgbClr val="3A2A05"/>
+                </a:solidFill>
+                <a:latin typeface="Cambria" pitchFamily="34" charset="0"/>
+                <a:ea typeface="Cambria" pitchFamily="34" charset="-122"/>
+                <a:cs typeface="Cambria" pitchFamily="34" charset="-120"/>
+              </a:rPr>
+              <a:t>6</a:t>
+            </a:r>
+            <a:endParaRPr lang="en-US" sz="1100" dirty="0"/>
+          </a:p>
+        </p:txBody>
+      </p:sp>
+      <p:sp>
+        <p:nvSpPr>
+          <p:cNvPr id="45" name="Shape 43"/>
+          <p:cNvSpPr/>
+          <p:nvPr/>
+        </p:nvSpPr>
+        <p:spPr>
+          <a:xfrm>
+            <a:off x="7973568" y="1773936"/>
+            <a:ext cx="3657600" cy="2852928"/>
+          </a:xfrm>
+          <a:prstGeom prst="roundRect">
+            <a:avLst>
+              <a:gd name="adj" fmla="val 1603"/>
+            </a:avLst>
+          </a:prstGeom>
+          <a:solidFill>
+            <a:srgbClr val="F4F7FE"/>
+          </a:solidFill>
+          <a:ln w="12700">
+            <a:solidFill>
+              <a:srgbClr val="C2D0EC"/>
+            </a:solidFill>
+            <a:prstDash val="solid"/>
+          </a:ln>
+        </p:spPr>
+      </p:sp>
+      <p:sp>
+        <p:nvSpPr>
+          <p:cNvPr id="46" name="Text 44"/>
+          <p:cNvSpPr/>
+          <p:nvPr/>
+        </p:nvSpPr>
+        <p:spPr>
+          <a:xfrm>
+            <a:off x="8083296" y="1819656"/>
+            <a:ext cx="3419856" cy="201168"/>
+          </a:xfrm>
+          <a:prstGeom prst="rect">
+            <a:avLst/>
+          </a:prstGeom>
+          <a:noFill/>
+          <a:ln/>
+        </p:spPr>
+        <p:txBody>
+          <a:bodyPr wrap="square" rtlCol="0" anchor="ctr"/>
+          <a:lstStyle/>
+          <a:p>
+            <a:pPr indent="0" marL="0">
+              <a:buNone/>
+            </a:pPr>
+            <a:r>
+              <a:rPr lang="en-US" sz="850" b="1" spc="100" kern="0" dirty="0">
+                <a:solidFill>
+                  <a:srgbClr val="1E2761"/>
+                </a:solidFill>
+              </a:rPr>
+              <a:t>MODEL LAYER — VPC ENDPOINT</a:t>
+            </a:r>
+            <a:endParaRPr lang="en-US" sz="850" dirty="0"/>
+          </a:p>
+        </p:txBody>
+      </p:sp>
+      <p:sp>
+        <p:nvSpPr>
+          <p:cNvPr id="47" name="Shape 45"/>
+          <p:cNvSpPr/>
+          <p:nvPr/>
+        </p:nvSpPr>
+        <p:spPr>
+          <a:xfrm>
+            <a:off x="8092440" y="2048256"/>
+            <a:ext cx="3419856" cy="512064"/>
+          </a:xfrm>
+          <a:prstGeom prst="roundRect">
+            <a:avLst>
+              <a:gd name="adj" fmla="val 7143"/>
+            </a:avLst>
+          </a:prstGeom>
+          <a:solidFill>
+            <a:srgbClr val="1E2761"/>
+          </a:solidFill>
+          <a:ln/>
+          <a:effectLst>
+            <a:outerShdw sx="100000" sy="100000" kx="0" ky="0" algn="bl" rotWithShape="0" blurRad="88900" dist="38100" dir="5400000">
+              <a:srgbClr val="000000">
+                <a:alpha val="15000"/>
+              </a:srgbClr>
+            </a:outerShdw>
+          </a:effectLst>
+        </p:spPr>
+      </p:sp>
+      <p:sp>
+        <p:nvSpPr>
+          <p:cNvPr id="48" name="Text 46"/>
+          <p:cNvSpPr/>
+          <p:nvPr/>
+        </p:nvSpPr>
+        <p:spPr>
+          <a:xfrm>
+            <a:off x="8147304" y="2048256"/>
+            <a:ext cx="3310128" cy="512064"/>
+          </a:xfrm>
+          <a:prstGeom prst="rect">
+            <a:avLst/>
+          </a:prstGeom>
+          <a:noFill/>
+          <a:ln/>
+        </p:spPr>
+        <p:txBody>
+          <a:bodyPr wrap="square" rtlCol="0" anchor="ctr"/>
+          <a:lstStyle/>
+          <a:p>
+            <a:pPr algn="ctr" indent="0" marL="0">
+              <a:buNone/>
+            </a:pPr>
+            <a:r>
+              <a:rPr lang="en-US" sz="880" dirty="0">
+                <a:solidFill>
+                  <a:srgbClr val="FFFFFF"/>
+                </a:solidFill>
+              </a:rPr>
+              <a:t>Amazon Bedrock — Claude Sonnet + Haiku</a:t>
+            </a:r>
+            <a:endParaRPr lang="en-US" sz="880" dirty="0"/>
+          </a:p>
+        </p:txBody>
+      </p:sp>
+      <p:sp>
+        <p:nvSpPr>
+          <p:cNvPr id="49" name="Shape 47"/>
+          <p:cNvSpPr/>
+          <p:nvPr/>
+        </p:nvSpPr>
+        <p:spPr>
+          <a:xfrm>
+            <a:off x="8001000" y="1975104"/>
+            <a:ext cx="274320" cy="274320"/>
+          </a:xfrm>
+          <a:prstGeom prst="ellipse">
+            <a:avLst/>
+          </a:prstGeom>
+          <a:solidFill>
+            <a:srgbClr val="E0A53B"/>
+          </a:solidFill>
+          <a:ln/>
+        </p:spPr>
+      </p:sp>
+      <p:sp>
+        <p:nvSpPr>
+          <p:cNvPr id="50" name="Text 48"/>
+          <p:cNvSpPr/>
+          <p:nvPr/>
+        </p:nvSpPr>
+        <p:spPr>
+          <a:xfrm>
+            <a:off x="8001000" y="1975104"/>
+            <a:ext cx="274320" cy="274320"/>
+          </a:xfrm>
+          <a:prstGeom prst="rect">
+            <a:avLst/>
+          </a:prstGeom>
+          <a:noFill/>
+          <a:ln/>
+        </p:spPr>
+        <p:txBody>
+          <a:bodyPr wrap="square" rtlCol="0" anchor="ctr"/>
+          <a:lstStyle/>
+          <a:p>
+            <a:pPr algn="ctr" indent="0" marL="0">
+              <a:buNone/>
+            </a:pPr>
+            <a:r>
+              <a:rPr lang="en-US" sz="1100" b="1" dirty="0">
+                <a:solidFill>
+                  <a:srgbClr val="3A2A05"/>
+                </a:solidFill>
+                <a:latin typeface="Cambria" pitchFamily="34" charset="0"/>
+                <a:ea typeface="Cambria" pitchFamily="34" charset="-122"/>
+                <a:cs typeface="Cambria" pitchFamily="34" charset="-120"/>
+              </a:rPr>
+              <a:t>5</a:t>
+            </a:r>
+            <a:endParaRPr lang="en-US" sz="1100" dirty="0"/>
+          </a:p>
+        </p:txBody>
+      </p:sp>
+      <p:sp>
+        <p:nvSpPr>
+          <p:cNvPr id="51" name="Shape 49"/>
+          <p:cNvSpPr/>
+          <p:nvPr/>
+        </p:nvSpPr>
+        <p:spPr>
+          <a:xfrm>
+            <a:off x="8092440" y="2633472"/>
+            <a:ext cx="3419856" cy="512064"/>
+          </a:xfrm>
+          <a:prstGeom prst="roundRect">
+            <a:avLst>
+              <a:gd name="adj" fmla="val 7143"/>
+            </a:avLst>
+          </a:prstGeom>
+          <a:solidFill>
+            <a:srgbClr val="2A376E"/>
+          </a:solidFill>
+          <a:ln/>
+          <a:effectLst>
+            <a:outerShdw sx="100000" sy="100000" kx="0" ky="0" algn="bl" rotWithShape="0" blurRad="88900" dist="38100" dir="5400000">
+              <a:srgbClr val="000000">
+                <a:alpha val="15000"/>
+              </a:srgbClr>
+            </a:outerShdw>
+          </a:effectLst>
+        </p:spPr>
+      </p:sp>
+      <p:sp>
+        <p:nvSpPr>
+          <p:cNvPr id="52" name="Text 50"/>
+          <p:cNvSpPr/>
+          <p:nvPr/>
+        </p:nvSpPr>
+        <p:spPr>
+          <a:xfrm>
+            <a:off x="8147304" y="2633472"/>
+            <a:ext cx="3310128" cy="512064"/>
+          </a:xfrm>
+          <a:prstGeom prst="rect">
+            <a:avLst/>
+          </a:prstGeom>
+          <a:noFill/>
+          <a:ln/>
+        </p:spPr>
+        <p:txBody>
+          <a:bodyPr wrap="square" rtlCol="0" anchor="ctr"/>
+          <a:lstStyle/>
+          <a:p>
+            <a:pPr algn="ctr" indent="0" marL="0">
+              <a:buNone/>
+            </a:pPr>
+            <a:r>
+              <a:rPr lang="en-US" sz="880" dirty="0">
+                <a:solidFill>
+                  <a:srgbClr val="FFFFFF"/>
+                </a:solidFill>
+              </a:rPr>
+              <a:t>Bedrock Guardrails — PII &amp; content (mandatory)</a:t>
+            </a:r>
+            <a:endParaRPr lang="en-US" sz="880" dirty="0"/>
+          </a:p>
+        </p:txBody>
+      </p:sp>
+      <p:sp>
+        <p:nvSpPr>
+          <p:cNvPr id="53" name="Text 51"/>
+          <p:cNvSpPr/>
+          <p:nvPr/>
+        </p:nvSpPr>
+        <p:spPr>
+          <a:xfrm>
+            <a:off x="8083296" y="3218688"/>
+            <a:ext cx="3419856" cy="201168"/>
+          </a:xfrm>
+          <a:prstGeom prst="rect">
+            <a:avLst/>
+          </a:prstGeom>
+          <a:noFill/>
+          <a:ln/>
+        </p:spPr>
+        <p:txBody>
+          <a:bodyPr wrap="square" rtlCol="0" anchor="ctr"/>
+          <a:lstStyle/>
+          <a:p>
+            <a:pPr indent="0" marL="0">
+              <a:buNone/>
+            </a:pPr>
+            <a:r>
+              <a:rPr lang="en-US" sz="850" b="1" spc="100" kern="0" dirty="0">
+                <a:solidFill>
+                  <a:srgbClr val="1E2761"/>
+                </a:solidFill>
+              </a:rPr>
+              <a:t>DATA TIER — KMS CMK per data class</a:t>
+            </a:r>
+            <a:endParaRPr lang="en-US" sz="850" dirty="0"/>
+          </a:p>
+        </p:txBody>
+      </p:sp>
+      <p:sp>
+        <p:nvSpPr>
+          <p:cNvPr id="54" name="Shape 52"/>
+          <p:cNvSpPr/>
+          <p:nvPr/>
+        </p:nvSpPr>
+        <p:spPr>
+          <a:xfrm>
+            <a:off x="8092440" y="3438144"/>
+            <a:ext cx="3419856" cy="512064"/>
+          </a:xfrm>
+          <a:prstGeom prst="roundRect">
+            <a:avLst>
+              <a:gd name="adj" fmla="val 7143"/>
+            </a:avLst>
+          </a:prstGeom>
+          <a:solidFill>
+            <a:srgbClr val="2A376E"/>
+          </a:solidFill>
+          <a:ln/>
+          <a:effectLst>
+            <a:outerShdw sx="100000" sy="100000" kx="0" ky="0" algn="bl" rotWithShape="0" blurRad="88900" dist="38100" dir="5400000">
+              <a:srgbClr val="000000">
+                <a:alpha val="15000"/>
+              </a:srgbClr>
+            </a:outerShdw>
+          </a:effectLst>
+        </p:spPr>
+      </p:sp>
+      <p:sp>
+        <p:nvSpPr>
+          <p:cNvPr id="55" name="Text 53"/>
+          <p:cNvSpPr/>
+          <p:nvPr/>
+        </p:nvSpPr>
+        <p:spPr>
+          <a:xfrm>
+            <a:off x="8147304" y="3438144"/>
+            <a:ext cx="3310128" cy="512064"/>
+          </a:xfrm>
+          <a:prstGeom prst="rect">
+            <a:avLst/>
+          </a:prstGeom>
+          <a:noFill/>
+          <a:ln/>
+        </p:spPr>
+        <p:txBody>
+          <a:bodyPr wrap="square" rtlCol="0" anchor="ctr"/>
+          <a:lstStyle/>
+          <a:p>
+            <a:pPr algn="ctr" indent="0" marL="0">
+              <a:buNone/>
+            </a:pPr>
+            <a:r>
+              <a:rPr lang="en-US" sz="880" dirty="0">
+                <a:solidFill>
+                  <a:srgbClr val="FFFFFF"/>
+                </a:solidFill>
+              </a:rPr>
+              <a:t>DynamoDB — append-only audit</a:t>
+            </a:r>
+            <a:endParaRPr lang="en-US" sz="880" dirty="0"/>
+          </a:p>
+        </p:txBody>
+      </p:sp>
+      <p:sp>
+        <p:nvSpPr>
+          <p:cNvPr id="56" name="Shape 54"/>
+          <p:cNvSpPr/>
+          <p:nvPr/>
+        </p:nvSpPr>
+        <p:spPr>
+          <a:xfrm>
+            <a:off x="8001000" y="3364992"/>
+            <a:ext cx="274320" cy="274320"/>
+          </a:xfrm>
+          <a:prstGeom prst="ellipse">
+            <a:avLst/>
+          </a:prstGeom>
+          <a:solidFill>
+            <a:srgbClr val="E0A53B"/>
+          </a:solidFill>
+          <a:ln/>
+        </p:spPr>
+      </p:sp>
+      <p:sp>
+        <p:nvSpPr>
+          <p:cNvPr id="57" name="Text 55"/>
+          <p:cNvSpPr/>
+          <p:nvPr/>
+        </p:nvSpPr>
+        <p:spPr>
+          <a:xfrm>
+            <a:off x="8001000" y="3364992"/>
+            <a:ext cx="274320" cy="274320"/>
+          </a:xfrm>
+          <a:prstGeom prst="rect">
+            <a:avLst/>
+          </a:prstGeom>
+          <a:noFill/>
+          <a:ln/>
+        </p:spPr>
+        <p:txBody>
+          <a:bodyPr wrap="square" rtlCol="0" anchor="ctr"/>
+          <a:lstStyle/>
+          <a:p>
+            <a:pPr algn="ctr" indent="0" marL="0">
+              <a:buNone/>
+            </a:pPr>
+            <a:r>
+              <a:rPr lang="en-US" sz="1100" b="1" dirty="0">
+                <a:solidFill>
+                  <a:srgbClr val="3A2A05"/>
+                </a:solidFill>
+                <a:latin typeface="Cambria" pitchFamily="34" charset="0"/>
+                <a:ea typeface="Cambria" pitchFamily="34" charset="-122"/>
+                <a:cs typeface="Cambria" pitchFamily="34" charset="-120"/>
+              </a:rPr>
+              <a:t>8</a:t>
+            </a:r>
+            <a:endParaRPr lang="en-US" sz="1100" dirty="0"/>
+          </a:p>
+        </p:txBody>
+      </p:sp>
+      <p:sp>
+        <p:nvSpPr>
+          <p:cNvPr id="58" name="Shape 56"/>
+          <p:cNvSpPr/>
+          <p:nvPr/>
+        </p:nvSpPr>
+        <p:spPr>
+          <a:xfrm>
+            <a:off x="8092440" y="4023360"/>
+            <a:ext cx="3419856" cy="512064"/>
+          </a:xfrm>
+          <a:prstGeom prst="roundRect">
+            <a:avLst>
+              <a:gd name="adj" fmla="val 7143"/>
+            </a:avLst>
+          </a:prstGeom>
+          <a:solidFill>
+            <a:srgbClr val="2A376E"/>
+          </a:solidFill>
+          <a:ln/>
+          <a:effectLst>
+            <a:outerShdw sx="100000" sy="100000" kx="0" ky="0" algn="bl" rotWithShape="0" blurRad="88900" dist="38100" dir="5400000">
+              <a:srgbClr val="000000">
+                <a:alpha val="15000"/>
+              </a:srgbClr>
+            </a:outerShdw>
+          </a:effectLst>
+        </p:spPr>
+      </p:sp>
+      <p:sp>
+        <p:nvSpPr>
+          <p:cNvPr id="59" name="Text 57"/>
+          <p:cNvSpPr/>
+          <p:nvPr/>
+        </p:nvSpPr>
+        <p:spPr>
+          <a:xfrm>
+            <a:off x="8147304" y="4023360"/>
+            <a:ext cx="3310128" cy="512064"/>
+          </a:xfrm>
+          <a:prstGeom prst="rect">
+            <a:avLst/>
+          </a:prstGeom>
+          <a:noFill/>
+          <a:ln/>
+        </p:spPr>
+        <p:txBody>
+          <a:bodyPr wrap="square" rtlCol="0" anchor="ctr"/>
+          <a:lstStyle/>
+          <a:p>
+            <a:pPr algn="ctr" indent="0" marL="0">
+              <a:buNone/>
+            </a:pPr>
+            <a:r>
+              <a:rPr lang="en-US" sz="880" dirty="0">
+                <a:solidFill>
+                  <a:srgbClr val="FFFFFF"/>
+                </a:solidFill>
+              </a:rPr>
+              <a:t>S3 Object Lock (WORM) · state · Secrets</a:t>
+            </a:r>
+            <a:endParaRPr lang="en-US" sz="880" dirty="0"/>
+          </a:p>
+        </p:txBody>
+      </p:sp>
+      <p:sp>
+        <p:nvSpPr>
+          <p:cNvPr id="60" name="Shape 58"/>
+          <p:cNvSpPr/>
+          <p:nvPr/>
+        </p:nvSpPr>
+        <p:spPr>
+          <a:xfrm>
+            <a:off x="8001000" y="3950208"/>
+            <a:ext cx="274320" cy="274320"/>
+          </a:xfrm>
+          <a:prstGeom prst="ellipse">
+            <a:avLst/>
+          </a:prstGeom>
+          <a:solidFill>
+            <a:srgbClr val="E0A53B"/>
+          </a:solidFill>
+          <a:ln/>
+        </p:spPr>
+      </p:sp>
+      <p:sp>
+        <p:nvSpPr>
+          <p:cNvPr id="61" name="Text 59"/>
+          <p:cNvSpPr/>
+          <p:nvPr/>
+        </p:nvSpPr>
+        <p:spPr>
+          <a:xfrm>
+            <a:off x="8001000" y="3950208"/>
+            <a:ext cx="274320" cy="274320"/>
+          </a:xfrm>
+          <a:prstGeom prst="rect">
+            <a:avLst/>
+          </a:prstGeom>
+          <a:noFill/>
+          <a:ln/>
+        </p:spPr>
+        <p:txBody>
+          <a:bodyPr wrap="square" rtlCol="0" anchor="ctr"/>
+          <a:lstStyle/>
+          <a:p>
+            <a:pPr algn="ctr" indent="0" marL="0">
+              <a:buNone/>
+            </a:pPr>
+            <a:r>
+              <a:rPr lang="en-US" sz="1100" b="1" dirty="0">
+                <a:solidFill>
+                  <a:srgbClr val="3A2A05"/>
+                </a:solidFill>
+                <a:latin typeface="Cambria" pitchFamily="34" charset="0"/>
+                <a:ea typeface="Cambria" pitchFamily="34" charset="-122"/>
+                <a:cs typeface="Cambria" pitchFamily="34" charset="-120"/>
+              </a:rPr>
+              <a:t>7</a:t>
+            </a:r>
+            <a:endParaRPr lang="en-US" sz="1100" dirty="0"/>
+          </a:p>
+        </p:txBody>
+      </p:sp>
+      <p:sp>
+        <p:nvSpPr>
+          <p:cNvPr id="62" name="Shape 60"/>
+          <p:cNvSpPr/>
+          <p:nvPr/>
+        </p:nvSpPr>
+        <p:spPr>
+          <a:xfrm>
+            <a:off x="2340864" y="3520440"/>
+            <a:ext cx="402336" cy="0"/>
+          </a:xfrm>
+          <a:prstGeom prst="line">
+            <a:avLst/>
+          </a:prstGeom>
+          <a:noFill/>
+          <a:ln w="19050">
+            <a:solidFill>
+              <a:srgbClr val="8FA0C8"/>
+            </a:solidFill>
+            <a:prstDash val="solid"/>
+          </a:ln>
+        </p:spPr>
+      </p:sp>
+      <p:sp>
+        <p:nvSpPr>
+          <p:cNvPr id="63" name="Shape 61"/>
+          <p:cNvSpPr/>
+          <p:nvPr/>
+        </p:nvSpPr>
+        <p:spPr>
+          <a:xfrm>
+            <a:off x="5138928" y="2322576"/>
+            <a:ext cx="329184" cy="0"/>
+          </a:xfrm>
+          <a:prstGeom prst="line">
+            <a:avLst/>
+          </a:prstGeom>
+          <a:noFill/>
+          <a:ln w="19050">
+            <a:solidFill>
+              <a:srgbClr val="8FA0C8"/>
+            </a:solidFill>
+            <a:prstDash val="solid"/>
+          </a:ln>
+        </p:spPr>
+      </p:sp>
+      <p:sp>
+        <p:nvSpPr>
+          <p:cNvPr id="64" name="Shape 62"/>
+          <p:cNvSpPr/>
+          <p:nvPr/>
+        </p:nvSpPr>
+        <p:spPr>
+          <a:xfrm>
+            <a:off x="7754112" y="2304288"/>
+            <a:ext cx="338328" cy="0"/>
+          </a:xfrm>
+          <a:prstGeom prst="line">
+            <a:avLst/>
+          </a:prstGeom>
+          <a:noFill/>
+          <a:ln w="19050">
+            <a:solidFill>
+              <a:srgbClr val="8FA0C8"/>
+            </a:solidFill>
+            <a:prstDash val="solid"/>
+          </a:ln>
+        </p:spPr>
+      </p:sp>
+      <p:sp>
+        <p:nvSpPr>
+          <p:cNvPr id="65" name="Shape 63"/>
+          <p:cNvSpPr/>
+          <p:nvPr/>
+        </p:nvSpPr>
+        <p:spPr>
+          <a:xfrm>
+            <a:off x="6611112" y="3383280"/>
+            <a:ext cx="0" cy="228600"/>
+          </a:xfrm>
+          <a:prstGeom prst="line">
+            <a:avLst/>
+          </a:prstGeom>
+          <a:noFill/>
+          <a:ln w="19050">
+            <a:solidFill>
+              <a:srgbClr val="8FA0C8"/>
+            </a:solidFill>
+            <a:prstDash val="solid"/>
+          </a:ln>
+        </p:spPr>
+      </p:sp>
+      <p:sp>
+        <p:nvSpPr>
+          <p:cNvPr id="66" name="Shape 64"/>
+          <p:cNvSpPr/>
+          <p:nvPr/>
+        </p:nvSpPr>
+        <p:spPr>
+          <a:xfrm>
+            <a:off x="457200" y="4828032"/>
+            <a:ext cx="11274552" cy="365760"/>
+          </a:xfrm>
+          <a:prstGeom prst="roundRect">
+            <a:avLst>
+              <a:gd name="adj" fmla="val 10000"/>
+            </a:avLst>
+          </a:prstGeom>
+          <a:solidFill>
             <a:srgbClr val="EEF2FB"/>
           </a:solidFill>
           <a:ln/>
@@ -4760,14 +6205,14 @@
       </p:sp>
       <p:sp>
         <p:nvSpPr>
-          <p:cNvPr id="19" name="Text 17"/>
-          <p:cNvSpPr/>
-          <p:nvPr/>
-        </p:nvSpPr>
-        <p:spPr>
-          <a:xfrm>
-            <a:off x="868680" y="3767328"/>
-            <a:ext cx="10424160" cy="420624"/>
+          <p:cNvPr id="67" name="Text 65"/>
+          <p:cNvSpPr/>
+          <p:nvPr/>
+        </p:nvSpPr>
+        <p:spPr>
+          <a:xfrm>
+            <a:off x="640080" y="4828032"/>
+            <a:ext cx="10972800" cy="365760"/>
           </a:xfrm>
           <a:prstGeom prst="rect">
             <a:avLst/>
@@ -4783,7 +6228,7 @@
               <a:buNone/>
             </a:pPr>
             <a:r>
-              <a:rPr lang="en-US" sz="1000" b="1" dirty="0">
+              <a:rPr lang="en-US" sz="930" b="1" dirty="0">
                 <a:solidFill>
                   <a:srgbClr val="1E2761"/>
                 </a:solidFill>
@@ -4794,27 +6239,27 @@
               <a:buNone/>
             </a:pPr>
             <a:r>
-              <a:rPr lang="en-US" sz="1000" dirty="0">
+              <a:rPr lang="en-US" sz="930" dirty="0">
                 <a:solidFill>
                   <a:srgbClr val="1B2440"/>
                 </a:solidFill>
               </a:rPr>
-              <a:t>KMS (CMK per data class) · IAM least-privilege roles · CloudWatch · CloudTrail · X-Ray · GuardDuty · Security Hub + Config · data-class isolation (CJI/FTI/PHI/EDU/public)</a:t>
-            </a:r>
-            <a:endParaRPr lang="en-US" sz="1000" dirty="0"/>
-          </a:p>
-        </p:txBody>
-      </p:sp>
-      <p:sp>
-        <p:nvSpPr>
-          <p:cNvPr id="20" name="Text 18"/>
-          <p:cNvSpPr/>
-          <p:nvPr/>
-        </p:nvSpPr>
-        <p:spPr>
-          <a:xfrm>
-            <a:off x="640080" y="4315968"/>
-            <a:ext cx="3657600" cy="274320"/>
+              <a:t>KMS (CMK per data class) · IAM least-privilege · CloudWatch · CloudTrail · X-Ray · GuardDuty · Security Hub + Config · data-class isolation (CJI/FTI/PHI/EDU/public)</a:t>
+            </a:r>
+            <a:endParaRPr lang="en-US" sz="930" dirty="0"/>
+          </a:p>
+        </p:txBody>
+      </p:sp>
+      <p:sp>
+        <p:nvSpPr>
+          <p:cNvPr id="68" name="Text 66"/>
+          <p:cNvSpPr/>
+          <p:nvPr/>
+        </p:nvSpPr>
+        <p:spPr>
+          <a:xfrm>
+            <a:off x="457200" y="5303520"/>
+            <a:ext cx="3657600" cy="219456"/>
           </a:xfrm>
           <a:prstGeom prst="rect">
             <a:avLst/>
@@ -4830,27 +6275,27 @@
               <a:buNone/>
             </a:pPr>
             <a:r>
-              <a:rPr lang="en-US" sz="1200" b="1" spc="100" kern="0" dirty="0">
+              <a:rPr lang="en-US" sz="1100" b="1" spc="100" kern="0" dirty="0">
                 <a:solidFill>
                   <a:srgbClr val="2E8BC0"/>
                 </a:solidFill>
               </a:rPr>
               <a:t>TRAFFIC FLOW</a:t>
             </a:r>
-            <a:endParaRPr lang="en-US" sz="1200" dirty="0"/>
-          </a:p>
-        </p:txBody>
-      </p:sp>
-      <p:sp>
-        <p:nvSpPr>
-          <p:cNvPr id="21" name="Text 19"/>
-          <p:cNvSpPr/>
-          <p:nvPr/>
-        </p:nvSpPr>
-        <p:spPr>
-          <a:xfrm>
-            <a:off x="640080" y="4617720"/>
-            <a:ext cx="10881360" cy="1691640"/>
+            <a:endParaRPr lang="en-US" sz="1100" dirty="0"/>
+          </a:p>
+        </p:txBody>
+      </p:sp>
+      <p:sp>
+        <p:nvSpPr>
+          <p:cNvPr id="69" name="Text 67"/>
+          <p:cNvSpPr/>
+          <p:nvPr/>
+        </p:nvSpPr>
+        <p:spPr>
+          <a:xfrm>
+            <a:off x="457200" y="5541264"/>
+            <a:ext cx="5623560" cy="1234440"/>
           </a:xfrm>
           <a:prstGeom prst="rect">
             <a:avLst/>
@@ -4869,14 +6314,14 @@
               <a:buNone/>
             </a:pPr>
             <a:r>
-              <a:rPr lang="en-US" sz="1050" dirty="0">
+              <a:rPr lang="en-US" sz="930" dirty="0">
                 <a:solidFill>
                   <a:srgbClr val="1B2440"/>
                 </a:solidFill>
               </a:rPr>
-              <a:t>1  Resident/staff sign in at the agency IdP (SAML/OIDC, MFA). Amazon Cognito brokers the assertion and issues a short-lived JWT — no credentials are stored in AWS.</a:t>
-            </a:r>
-            <a:endParaRPr lang="en-US" sz="1050" dirty="0"/>
+              <a:t>1  Resident/staff sign in at the agency IdP (SAML/OIDC, MFA). Amazon Cognito …</a:t>
+            </a:r>
+            <a:endParaRPr lang="en-US" sz="930" dirty="0"/>
           </a:p>
           <a:p>
             <a:pPr indent="0" marL="0">
@@ -4886,14 +6331,14 @@
               <a:buNone/>
             </a:pPr>
             <a:r>
-              <a:rPr lang="en-US" sz="1050" dirty="0">
+              <a:rPr lang="en-US" sz="930" dirty="0">
                 <a:solidFill>
                   <a:srgbClr val="1B2440"/>
                 </a:solidFill>
               </a:rPr>
-              <a:t>2  CloudFront + AWS WAF inspect, filter and rate-limit the request; API Gateway's Cognito JWT authorizer validates the token before any request reaches the app.</a:t>
-            </a:r>
-            <a:endParaRPr lang="en-US" sz="1050" dirty="0"/>
+              <a:t>2  CloudFront + AWS WAF inspect, filter and rate-limit the request; API Gatew…</a:t>
+            </a:r>
+            <a:endParaRPr lang="en-US" sz="930" dirty="0"/>
           </a:p>
           <a:p>
             <a:pPr indent="0" marL="0">
@@ -4903,14 +6348,14 @@
               <a:buNone/>
             </a:pPr>
             <a:r>
-              <a:rPr lang="en-US" sz="1050" dirty="0">
+              <a:rPr lang="en-US" sz="930" dirty="0">
                 <a:solidFill>
                   <a:srgbClr val="1B2440"/>
                 </a:solidFill>
               </a:rPr>
-              <a:t>3  The MCP gateway re-validates the JWT and its custom:slg_role claim and authorizes each tool call — agent grant ∩ user entitlement (deny-by-default).</a:t>
-            </a:r>
-            <a:endParaRPr lang="en-US" sz="1050" dirty="0"/>
+              <a:t>3  The MCP gateway re-validates the JWT and its custom:slg_role claim and aut…</a:t>
+            </a:r>
+            <a:endParaRPr lang="en-US" sz="930" dirty="0"/>
           </a:p>
           <a:p>
             <a:pPr indent="0" marL="0">
@@ -4920,15 +6365,37 @@
               <a:buNone/>
             </a:pPr>
             <a:r>
-              <a:rPr lang="en-US" sz="1050" dirty="0">
+              <a:rPr lang="en-US" sz="930" dirty="0">
                 <a:solidFill>
                   <a:srgbClr val="1B2440"/>
                 </a:solidFill>
               </a:rPr>
-              <a:t>4  For each authorized call the gateway mints a short-lived, tool-scoped token (AgentCore Identity / STS) — no standing service accounts; the JWT subject stays attributable.</a:t>
-            </a:r>
-            <a:endParaRPr lang="en-US" sz="1050" dirty="0"/>
-          </a:p>
+              <a:t>4  For each authorized call the gateway mints a short-lived, tool-scoped toke…</a:t>
+            </a:r>
+            <a:endParaRPr lang="en-US" sz="930" dirty="0"/>
+          </a:p>
+        </p:txBody>
+      </p:sp>
+      <p:sp>
+        <p:nvSpPr>
+          <p:cNvPr id="70" name="Text 68"/>
+          <p:cNvSpPr/>
+          <p:nvPr/>
+        </p:nvSpPr>
+        <p:spPr>
+          <a:xfrm>
+            <a:off x="6172200" y="5541264"/>
+            <a:ext cx="5577840" cy="1234440"/>
+          </a:xfrm>
+          <a:prstGeom prst="rect">
+            <a:avLst/>
+          </a:prstGeom>
+          <a:noFill/>
+          <a:ln/>
+        </p:spPr>
+        <p:txBody>
+          <a:bodyPr wrap="square" rtlCol="0" anchor="ctr"/>
+          <a:lstStyle/>
           <a:p>
             <a:pPr indent="0" marL="0">
               <a:spcAft>
@@ -4937,14 +6404,14 @@
               <a:buNone/>
             </a:pPr>
             <a:r>
-              <a:rPr lang="en-US" sz="1050" dirty="0">
+              <a:rPr lang="en-US" sz="930" dirty="0">
                 <a:solidFill>
                   <a:srgbClr val="1B2440"/>
                 </a:solidFill>
               </a:rPr>
-              <a:t>5  Model calls stay inside AWS via a Bedrock VPC endpoint; Guardrails filter PII/content on every call. Grounding, accessibility and PII checks run before a human sees output.</a:t>
-            </a:r>
-            <a:endParaRPr lang="en-US" sz="1050" dirty="0"/>
+              <a:t>5  Model calls stay inside AWS via a Bedrock VPC endpoint; Guardrails filter …</a:t>
+            </a:r>
+            <a:endParaRPr lang="en-US" sz="930" dirty="0"/>
           </a:p>
           <a:p>
             <a:pPr indent="0" marL="0">
@@ -4954,14 +6421,14 @@
               <a:buNone/>
             </a:pPr>
             <a:r>
-              <a:rPr lang="en-US" sz="1050" dirty="0">
+              <a:rPr lang="en-US" sz="930" dirty="0">
                 <a:solidFill>
                   <a:srgbClr val="1B2440"/>
                 </a:solidFill>
               </a:rPr>
-              <a:t>6  Workflow pauses at the human-review gate (Step Functions waitForTaskToken) — a named official, identified by the same JWT, approves.</a:t>
-            </a:r>
-            <a:endParaRPr lang="en-US" sz="1050" dirty="0"/>
+              <a:t>6  Workflow pauses at the human-review gate (Step Functions waitForTaskToken)…</a:t>
+            </a:r>
+            <a:endParaRPr lang="en-US" sz="930" dirty="0"/>
           </a:p>
           <a:p>
             <a:pPr indent="0" marL="0">
@@ -4971,14 +6438,14 @@
               <a:buNone/>
             </a:pPr>
             <a:r>
-              <a:rPr lang="en-US" sz="1050" dirty="0">
+              <a:rPr lang="en-US" sz="930" dirty="0">
                 <a:solidFill>
                   <a:srgbClr val="1B2440"/>
                 </a:solidFill>
               </a:rPr>
-              <a:t>7  On approval the action commits; case state, append-only audit and finalized records persist (S3 Object Lock WORM).</a:t>
-            </a:r>
-            <a:endParaRPr lang="en-US" sz="1050" dirty="0"/>
+              <a:t>7  On approval the action commits; case state, append-only audit and finalize…</a:t>
+            </a:r>
+            <a:endParaRPr lang="en-US" sz="930" dirty="0"/>
           </a:p>
           <a:p>
             <a:pPr indent="0" marL="0">
@@ -4988,14 +6455,14 @@
               <a:buNone/>
             </a:pPr>
             <a:r>
-              <a:rPr lang="en-US" sz="1050" dirty="0">
+              <a:rPr lang="en-US" sz="930" dirty="0">
                 <a:solidFill>
                   <a:srgbClr val="1B2440"/>
                 </a:solidFill>
               </a:rPr>
-              <a:t>8  Every step — node, timestamp, JWT subject/actor, data sources, model version — lands in one examiner-ready audit trail.</a:t>
-            </a:r>
-            <a:endParaRPr lang="en-US" sz="1050" dirty="0"/>
+              <a:t>8  Every step — node, timestamp, JWT subject/actor, data sources, model versi…</a:t>
+            </a:r>
+            <a:endParaRPr lang="en-US" sz="930" dirty="0"/>
           </a:p>
         </p:txBody>
       </p:sp>

</xml_diff>

<commit_message>
Add first-meeting cheatsheet, update README, decks, and platform docs
- New gtm/SELLER-FIRST-MEETING-CHEATSHEET.md
- Expanded README with additional detail
- Updated ENTERPRISE-PLATFORM.md and SUITE-STATUS.md
- Refreshed all 9 decks and DECK-SOURCES.md
- Updated WoG orchestration README

Co-Authored-By: Claude Opus 4.6 (1M context) <noreply@anthropic.com>
</commit_message>
<xml_diff>
--- a/decks/SLG-01-Resident-Services-311.pptx
+++ b/decks/SLG-01-Resident-Services-311.pptx
@@ -6632,7 +6632,7 @@
                   <a:srgbClr val="CADCFC"/>
                 </a:solidFill>
               </a:rPr>
-              <a:t>MEASURED OUTCOMES (illustrative for a reference agency; sources cited)</a:t>
+              <a:t>MEASURED OUTCOMES — documented results from named deployments &amp; published benchmarks (vendor-reported where noted)</a:t>
             </a:r>
             <a:endParaRPr lang="en-US" sz="1200" dirty="0"/>
           </a:p>
@@ -6671,7 +6671,7 @@
                 <a:ea typeface="Cambria" pitchFamily="34" charset="-122"/>
                 <a:cs typeface="Cambria" pitchFamily="34" charset="-120"/>
               </a:rPr>
-              <a:t>35%</a:t>
+              <a:t>−35%</a:t>
             </a:r>
             <a:endParaRPr lang="en-US" sz="3200" dirty="0"/>
           </a:p>
@@ -6707,7 +6707,7 @@
                   <a:srgbClr val="CADCFC"/>
                 </a:solidFill>
               </a:rPr>
-              <a:t>fewer live calls (TxGov benchmark)</a:t>
+              <a:t>call-center volume (Grupo TX 'TxGov')</a:t>
             </a:r>
             <a:endParaRPr lang="en-US" sz="1150" dirty="0"/>
           </a:p>
@@ -6746,7 +6746,7 @@
                 <a:ea typeface="Cambria" pitchFamily="34" charset="-122"/>
                 <a:cs typeface="Cambria" pitchFamily="34" charset="-120"/>
               </a:rPr>
-              <a:t>~80x</a:t>
+              <a:t>50% faster</a:t>
             </a:r>
             <a:endParaRPr lang="en-US" sz="3200" dirty="0"/>
           </a:p>
@@ -6782,7 +6782,7 @@
                   <a:srgbClr val="CADCFC"/>
                 </a:solidFill>
               </a:rPr>
-              <a:t>cheaper per self-service contact</a:t>
+              <a:t>response, 48h→24h (TxGov)</a:t>
             </a:r>
             <a:endParaRPr lang="en-US" sz="1150" dirty="0"/>
           </a:p>
@@ -6821,7 +6821,7 @@
                 <a:ea typeface="Cambria" pitchFamily="34" charset="-122"/>
                 <a:cs typeface="Cambria" pitchFamily="34" charset="-120"/>
               </a:rPr>
-              <a:t>24/7</a:t>
+              <a:t>−4,000/mo</a:t>
             </a:r>
             <a:endParaRPr lang="en-US" sz="3200" dirty="0"/>
           </a:p>
@@ -6857,7 +6857,7 @@
                   <a:srgbClr val="CADCFC"/>
                 </a:solidFill>
               </a:rPr>
-              <a:t>multilingual, accessible access</a:t>
+              <a:t>calls deflected (Indiana 311)</a:t>
             </a:r>
             <a:endParaRPr lang="en-US" sz="1150" dirty="0"/>
           </a:p>
@@ -6896,7 +6896,7 @@
                 <a:ea typeface="Cambria" pitchFamily="34" charset="-122"/>
                 <a:cs typeface="Cambria" pitchFamily="34" charset="-120"/>
               </a:rPr>
-              <a:t>50%</a:t>
+              <a:t>~80×</a:t>
             </a:r>
             <a:endParaRPr lang="en-US" sz="3200" dirty="0"/>
           </a:p>
@@ -6932,7 +6932,7 @@
                   <a:srgbClr val="CADCFC"/>
                 </a:solidFill>
               </a:rPr>
-              <a:t>faster response (48h→24h, TxGov)</a:t>
+              <a:t>cheaper per self-service contact</a:t>
             </a:r>
             <a:endParaRPr lang="en-US" sz="1150" dirty="0"/>
           </a:p>
@@ -7297,7 +7297,7 @@
                   <a:srgbClr val="5B6488"/>
                 </a:solidFill>
               </a:rPr>
-              <a:t>Sources: Gartner 2019 (cost per contact)  ·  AWS Public Sector 2026 (Grupo TX, Virginia Beach, Anne Arundel)</a:t>
+              <a:t>Sources: AWS Public Sector 2026 (Grupo TX TxGov; Virginia Beach 1,300+)  ·  Indiana 311 / Tars — vendor-reported  ·  Gartner 2019 (cost per contact)</a:t>
             </a:r>
             <a:endParaRPr lang="en-US" sz="850" dirty="0"/>
           </a:p>

</xml_diff>

<commit_message>
Update all 8 agent customer decks
Co-Authored-By: Claude Opus 4.6 (1M context) <noreply@anthropic.com>
</commit_message>
<xml_diff>
--- a/decks/SLG-01-Resident-Services-311.pptx
+++ b/decks/SLG-01-Resident-Services-311.pptx
@@ -507,7 +507,9 @@
           <a:p>
             <a:r>
               <a:rPr lang="en-US" dirty="0"/>
-              <a:t>TIMING ~1.5 min. Open on the resident experience: 'A resident wants to do one thing — renew a license, report a pothole, check an application — and faces dozens of departments and no single front door.' Set up that the hard part is governance, not the model.</a:t>
+              <a:t>TIMING ~1.5 min.
+SHOW: title, your name/role, the suite kicker.
+SAY: 'A resident wants to do one thing — renew a license, report a pothole, check an application — and faces dozens of departments and no front door. I'll show a governed agent that fixes that, and why the hard part is governance, not the model.'</a:t>
             </a:r>
             <a:endParaRPr lang="en-US" dirty="0"/>
           </a:p>
@@ -595,7 +597,10 @@
           <a:p>
             <a:r>
               <a:rPr lang="en-US" dirty="0"/>
-              <a:t>TIMING ~2.5 min. Hook with the economics: a live contact costs roughly $8 versus a dime for self-service (Gartner) — about 80x. A governed government agent (Grupo TX's TxGov, AWS Jun 2026) cut call volume 35% and halved response time; Virginia Beach's assistant fielded 1,300+ queries in month one. Land the point: deflection at government volume is seven figures.</a:t>
+              <a:t>TIMING ~2.5 min.
+SHOW: the FROM 6 SYSTEMS → ONE ANSWER headline and three stat cards with sources.
+SAY: 'A live contact costs about $8 versus a dime for self-service — roughly 80x, per Gartner. Grupo TX's TxGov cut call volume 35% and halved response time; Virginia Beach's assistant took 1,300+ questions in month one.'
+LAND IT: 'Deflection at government volume is seven figures — and this does it without a chatbot you can't audit.'</a:t>
             </a:r>
             <a:endParaRPr lang="en-US" dirty="0"/>
           </a:p>
@@ -683,7 +688,10 @@
           <a:p>
             <a:r>
               <a:rPr lang="en-US" dirty="0"/>
-              <a:t>TIMING ~3 min. Walk the situation, then 'what they need' across business/technical/regulatory. Emphasize the constraint: personal data is never disclosed on a name + address alone — identity must be verified. That single rule is what makes a CISO comfortable.</a:t>
+              <a:t>TIMING ~3 min.
+SHOW: THE SITUATION (left), WHAT THEY NEED — business/technical/regulatory (right), the navy constraint bar.
+SAY: 'Walk the fragmentation, then what they need. Then the constraint bar — that's the whole pitch: personal account data is never disclosed on a name and address alone; identity must be verified.'
+EMPHASIZE: 'That one rule is what makes a CISO comfortable letting AI near constituent data.'</a:t>
             </a:r>
             <a:endParaRPr lang="en-US" dirty="0"/>
           </a:p>
@@ -771,7 +779,10 @@
           <a:p>
             <a:r>
               <a:rPr lang="en-US" dirty="0"/>
-              <a:t>TIMING ~4 min. Walk the six steps. The green node is the human gate — 'the workflow cannot pass it; it's interrupt_before in the framework, not a line in a policy doc.' Close on the three trust callouts.</a:t>
+              <a:t>TIMING ~4 min.
+SHOW: the six-step pipeline; the GREEN node is the human gate; the three trust cards.
+SAY: 'Classify intent and agency, retrieve approved content with citations, verify identity if personal data is involved, draft and compliance-check, then the green human gate, then finalize.'
+POINT AT THE GREEN NODE: 'The workflow cannot pass this — it's interrupt_before in the framework, not a line in a policy doc.'</a:t>
             </a:r>
             <a:endParaRPr lang="en-US" dirty="0"/>
           </a:p>
@@ -859,7 +870,10 @@
           <a:p>
             <a:r>
               <a:rPr lang="en-US" dirty="0"/>
-              <a:t>TIMING ~5 min. Walk the numbered flow in order. Identity first (federation, no creds in AWS); model calls stay in-account via a Bedrock VPC endpoint; the MCP gateway is the single chokepoint for every tool call; append-only audit + WORM. Soundbite: 'one chokepoint to secure and audit, instead of N integrations.'</a:t>
+              <a:t>TIMING ~5 min.
+SHOW: the AWS architecture diagram; walk the numbered traffic-flow 1 to 8.
+SAY: 'Identity first: residents authenticate at the agency IdP; Cognito issues a short-lived JWT — no credentials in AWS. CloudFront and WAF filter at the edge; the JWT is validated at API Gateway, then re-checked by the MCP gateway, which mints a scoped per-call token. Model calls stay in-account via a Bedrock VPC endpoint; every action lands in append-only audit plus WORM.'
+SOUNDBITE: 'One chokepoint to secure and audit, instead of N integrations. And note the deployment banner — this agent runs standalone; the WoG platform is optional.'</a:t>
             </a:r>
             <a:endParaRPr lang="en-US" dirty="0"/>
           </a:p>
@@ -947,7 +961,10 @@
           <a:p>
             <a:r>
               <a:rPr lang="en-US" dirty="0"/>
-              <a:t>TIMING ~4 min. Be honest: figures are modeled from cited benchmarks for a reference city, not a longitudinal study. Results: ~35% deflection, ~80x cheaper self-service, 24/7 accessible access. Close: same trust architecture plugs into the whole-of-government platform — this agent is also a step in the 'moving' life-event saga.</a:t>
+              <a:t>TIMING ~4 min.
+SHOW: the outcomes band, the two cards, the takeaway.
+SAY: 'Documented results from named deployments: TxGov −35% call volume and 50% faster; Indiana 311 deflecting about 4,000 calls a month; about 80x cheaper per self-service contact.'
+TRADEOFF TALK TRACK — what I chose and what it cost: (1) the human gate caps full automation, but that's the point — nothing irreversible without a person; (2) in-account Bedrock over the newest model — I trade model-of-the-week for no PII egress and one governance point; (3) identity-gating adds a step but prevents wrongful disclosure. CLOSE: 'The agent isn't the product — the governance that makes it deployable and auditable is. This agent is also the front door for the moving life-event.'</a:t>
             </a:r>
             <a:endParaRPr lang="en-US" dirty="0"/>
           </a:p>
@@ -7037,7 +7054,7 @@
                   <a:srgbClr val="1B2440"/>
                 </a:solidFill>
               </a:rPr>
-              <a:t>Human gate caps full automation — the consequential action is the point.</a:t>
+              <a:t>Human gate over straight-through automation — every consequential 311 write pauses for a city reviewer. Cost: not 100% hands-off; payoff: nothing irreversible happens without an accountable person.</a:t>
             </a:r>
             <a:endParaRPr lang="en-US" sz="1100" dirty="0"/>
           </a:p>
@@ -7055,7 +7072,7 @@
                   <a:srgbClr val="1B2440"/>
                 </a:solidFill>
               </a:rPr>
-              <a:t>Bedrock (VPC-private, governed) over best-model-of-the-week; abstracted via an LLM factory.</a:t>
+              <a:t>In-account Bedrock over best-model-of-the-week — models sit behind an LLM factory and swap without code change. Cost: not always the newest model; payoff: VPC-private inference, no PII egress, one governance point.</a:t>
             </a:r>
             <a:endParaRPr lang="en-US" sz="1100" dirty="0"/>
           </a:p>
@@ -7073,7 +7090,7 @@
                   <a:srgbClr val="1B2440"/>
                 </a:solidFill>
               </a:rPr>
-              <a:t>Portable gateway path chosen for GovCloud day-one deployability.</a:t>
+              <a:t>Identity-gated personal data over frictionless answers — a name + address never unlocks account data. Cost: an extra verification step; payoff: no wrongful disclosure.</a:t>
             </a:r>
             <a:endParaRPr lang="en-US" sz="1100" dirty="0"/>
           </a:p>

</xml_diff>

<commit_message>
Harden TokenSecret, add architecture diagrams and maturity matrix, clean up obsolete files
- Remove dev-default TokenSecret from all 8 golden path templates; enforce MinLength 32
- Deploy scripts auto-generate strong random secrets; smoke tests fail-fast without one
- Add capability maturity matrix and architecture diagrams (data flow, MCP gateway auth)
- Add clean-account acceptance evidence pack
- Remove obsolete files (IMPROVEMENTS-OVER-EDU-HCLS.md, REVIEW-2-IMPROVEMENTS-BACKLOG.md, QA images)
- Update terminology: "in-account inference" → "private-connectivity inference" (PrivateLink)
- Update SECURITY.md to use GitHub Security Advisories for vulnerability reports
- Update LICENSE copyright

Co-Authored-By: Claude Opus 4.6 (1M context) <noreply@anthropic.com>
</commit_message>
<xml_diff>
--- a/decks/SLG-01-Resident-Services-311.pptx
+++ b/decks/SLG-01-Resident-Services-311.pptx
@@ -7397,28 +7397,28 @@
         <a:sysClr val="window" lastClr="FFFFFF"/>
       </a:lt1>
       <a:dk2>
-        <a:srgbClr val="44546A"/>
+        <a:srgbClr val="232F3E"/>
       </a:dk2>
       <a:lt2>
         <a:srgbClr val="E7E6E6"/>
       </a:lt2>
       <a:accent1>
-        <a:srgbClr val="4472C4"/>
+        <a:srgbClr val="FF9900"/>
       </a:accent1>
       <a:accent2>
-        <a:srgbClr val="ED7D31"/>
+        <a:srgbClr val="232F3E"/>
       </a:accent2>
       <a:accent3>
-        <a:srgbClr val="A5A5A5"/>
+        <a:srgbClr val="01A88D"/>
       </a:accent3>
       <a:accent4>
-        <a:srgbClr val="FFC000"/>
+        <a:srgbClr val="8C4FFF"/>
       </a:accent4>
       <a:accent5>
-        <a:srgbClr val="5B9BD5"/>
+        <a:srgbClr val="DD344C"/>
       </a:accent5>
       <a:accent6>
-        <a:srgbClr val="70AD47"/>
+        <a:srgbClr val="ED7100"/>
       </a:accent6>
       <a:hlink>
         <a:srgbClr val="0563C1"/>
@@ -7429,7 +7429,7 @@
     </a:clrScheme>
     <a:fontScheme name="Office">
       <a:majorFont>
-        <a:latin typeface="Trebuchet MS"/>
+        <a:latin typeface="Amazon Ember"/>
         <a:ea typeface=""/>
         <a:cs typeface=""/>
         <a:font script="Jpan" typeface="游ゴシック Light"/>
@@ -7481,7 +7481,7 @@
         <a:font script="Tfng" typeface="Ebrima"/>
       </a:majorFont>
       <a:minorFont>
-        <a:latin typeface="Calibri"/>
+        <a:latin typeface="Amazon Ember"/>
         <a:ea typeface=""/>
         <a:cs typeface=""/>
         <a:font script="Jpan" typeface="游ゴシック"/>

</xml_diff>

<commit_message>
Add origin cloaking, IAM-layer audit deny, secure smoke/destroy scripts, assurance packet
- Origin cloaking for secure variants: connector + reviewer handlers check X-Origin-Verify
  header (CloudFront-injected secret); direct execute-api calls rejected with 403
- IAM-layer append-only audit enforcement: explicit Deny on UpdateItem/DeleteItem for the
  audit table in all 16 golden-path templates (base + secure)
- New smoke_test.sh for all 8 secure variants (edge probe, cloaking assertion, approval controls)
- New destroy.sh for all 8 secure variants (clean teardown of retained resources)
- New assurance/ packet: GRC/auditor cover sheet indexing all compliance artifacts
- Evidence updated with secure-variant live validation results
- Deck file size optimization across all 21 .pptx files

Co-Authored-By: Claude Opus 4.6 (1M context) <noreply@anthropic.com>
</commit_message>
<xml_diff>
--- a/decks/SLG-01-Resident-Services-311.pptx
+++ b/decks/SLG-01-Resident-Services-311.pptx
@@ -11,6 +11,7 @@
     <p:sldId id="259" r:id="rId5"/>
     <p:sldId id="260" r:id="rId6"/>
     <p:sldId id="261" r:id="rId7"/>
+    <p:sldId id="262" r:id="rId13"/>
   </p:sldIdLst>
   <p:notesMasterIdLst>
     <p:notesMasterId r:id="rId8"/>
@@ -1589,6 +1590,40 @@
           </a:p>
         </p:txBody>
       </p:sp>
+      <p:sp>
+        <p:nvSpPr>
+          <p:cNvPr id="9" name="TextBox 8"/>
+          <p:cNvSpPr txBox="1"/>
+          <p:nvPr/>
+        </p:nvSpPr>
+        <p:spPr>
+          <a:xfrm>
+            <a:off x="365760" y="6291072"/>
+            <a:ext cx="11460175" cy="457200"/>
+          </a:xfrm>
+          <a:prstGeom prst="rect">
+            <a:avLst/>
+          </a:prstGeom>
+          <a:noFill/>
+        </p:spPr>
+        <p:txBody>
+          <a:bodyPr wrap="square" tIns="0" bIns="0">
+            <a:spAutoFit/>
+          </a:bodyPr>
+          <a:lstStyle/>
+          <a:p>
+            <a:pPr algn="l"/>
+            <a:r>
+              <a:rPr sz="800" i="1">
+                <a:solidFill>
+                  <a:srgbClr val="879296"/>
+                </a:solidFill>
+              </a:rPr>
+              <a:t>Reference accelerator — not an AWS service, not AWS-supported software, not a compliance certification, and not production-ready for regulated data without customer-specific engineering, testing, authorization, and operational ownership.</a:t>
+            </a:r>
+          </a:p>
+        </p:txBody>
+      </p:sp>
     </p:spTree>
   </p:cSld>
   <p:clrMapOvr>
@@ -7375,6 +7410,198 @@
               <a:t>Figures are documented outcomes from named deployments, labeled by evidence tier. Vendor-reported vs. government/peer-reviewed sourcing in DECK-SOURCES.md. Improvement applied to a reference agency — not a guarantee.</a:t>
             </a:r>
             <a:endParaRPr lang="en-US" sz="830" dirty="0"/>
+          </a:p>
+        </p:txBody>
+      </p:sp>
+    </p:spTree>
+  </p:cSld>
+  <p:clrMapOvr>
+    <a:masterClrMapping/>
+  </p:clrMapOvr>
+</p:sld>
+</file>
+
+<file path=ppt/slides/slide7.xml><?xml version="1.0" encoding="utf-8"?>
+<p:sld xmlns:a="http://schemas.openxmlformats.org/drawingml/2006/main" xmlns:p="http://schemas.openxmlformats.org/presentationml/2006/main" xmlns:r="http://schemas.openxmlformats.org/officeDocument/2006/relationships">
+  <p:cSld>
+    <p:spTree>
+      <p:nvGrpSpPr>
+        <p:cNvPr id="1" name=""/>
+        <p:cNvGrpSpPr/>
+        <p:nvPr/>
+      </p:nvGrpSpPr>
+      <p:grpSpPr/>
+      <p:sp>
+        <p:nvSpPr>
+          <p:cNvPr id="2" name="Rectangle 1"/>
+          <p:cNvSpPr/>
+          <p:nvPr/>
+        </p:nvSpPr>
+        <p:spPr>
+          <a:xfrm>
+            <a:off x="0" y="0"/>
+            <a:ext cx="12191695" cy="6858000"/>
+          </a:xfrm>
+          <a:prstGeom prst="rect">
+            <a:avLst/>
+          </a:prstGeom>
+          <a:solidFill>
+            <a:srgbClr val="232F3E"/>
+          </a:solidFill>
+          <a:ln>
+            <a:noFill/>
+          </a:ln>
+          <a:effectLst/>
+        </p:spPr>
+        <p:style>
+          <a:lnRef idx="1">
+            <a:schemeClr val="accent1"/>
+          </a:lnRef>
+          <a:fillRef idx="3">
+            <a:schemeClr val="accent1"/>
+          </a:fillRef>
+          <a:effectRef idx="2">
+            <a:schemeClr val="accent1"/>
+          </a:effectRef>
+          <a:fontRef idx="minor">
+            <a:schemeClr val="lt1"/>
+          </a:fontRef>
+        </p:style>
+        <p:txBody>
+          <a:bodyPr rtlCol="0" anchor="ctr"/>
+          <a:lstStyle/>
+          <a:p>
+            <a:pPr algn="ctr"/>
+          </a:p>
+        </p:txBody>
+      </p:sp>
+      <p:sp>
+        <p:nvSpPr>
+          <p:cNvPr id="3" name="Rectangle 2"/>
+          <p:cNvSpPr/>
+          <p:nvPr/>
+        </p:nvSpPr>
+        <p:spPr>
+          <a:xfrm>
+            <a:off x="822960" y="1051560"/>
+            <a:ext cx="2011680" cy="82296"/>
+          </a:xfrm>
+          <a:prstGeom prst="rect">
+            <a:avLst/>
+          </a:prstGeom>
+          <a:solidFill>
+            <a:srgbClr val="FF9900"/>
+          </a:solidFill>
+          <a:ln>
+            <a:noFill/>
+          </a:ln>
+          <a:effectLst/>
+        </p:spPr>
+        <p:style>
+          <a:lnRef idx="1">
+            <a:schemeClr val="accent1"/>
+          </a:lnRef>
+          <a:fillRef idx="3">
+            <a:schemeClr val="accent1"/>
+          </a:fillRef>
+          <a:effectRef idx="2">
+            <a:schemeClr val="accent1"/>
+          </a:effectRef>
+          <a:fontRef idx="minor">
+            <a:schemeClr val="lt1"/>
+          </a:fontRef>
+        </p:style>
+        <p:txBody>
+          <a:bodyPr rtlCol="0" anchor="ctr"/>
+          <a:lstStyle/>
+          <a:p>
+            <a:pPr algn="ctr"/>
+          </a:p>
+        </p:txBody>
+      </p:sp>
+      <p:sp>
+        <p:nvSpPr>
+          <p:cNvPr id="4" name="TextBox 3"/>
+          <p:cNvSpPr txBox="1"/>
+          <p:nvPr/>
+        </p:nvSpPr>
+        <p:spPr>
+          <a:xfrm>
+            <a:off x="822960" y="1234440"/>
+            <a:ext cx="10545775" cy="914400"/>
+          </a:xfrm>
+          <a:prstGeom prst="rect">
+            <a:avLst/>
+          </a:prstGeom>
+          <a:noFill/>
+        </p:spPr>
+        <p:txBody>
+          <a:bodyPr wrap="square">
+            <a:spAutoFit/>
+          </a:bodyPr>
+          <a:lstStyle/>
+          <a:p>
+            <a:r>
+              <a:rPr sz="3400" b="1">
+                <a:solidFill>
+                  <a:srgbClr val="FFFFFF"/>
+                </a:solidFill>
+              </a:rPr>
+              <a:t>Disclaimer &amp; Shared Responsibility</a:t>
+            </a:r>
+          </a:p>
+        </p:txBody>
+      </p:sp>
+      <p:sp>
+        <p:nvSpPr>
+          <p:cNvPr id="5" name="TextBox 4"/>
+          <p:cNvSpPr txBox="1"/>
+          <p:nvPr/>
+        </p:nvSpPr>
+        <p:spPr>
+          <a:xfrm>
+            <a:off x="822960" y="2468880"/>
+            <a:ext cx="10545775" cy="3108960"/>
+          </a:xfrm>
+          <a:prstGeom prst="rect">
+            <a:avLst/>
+          </a:prstGeom>
+          <a:noFill/>
+        </p:spPr>
+        <p:txBody>
+          <a:bodyPr wrap="square">
+            <a:spAutoFit/>
+          </a:bodyPr>
+          <a:lstStyle/>
+          <a:p>
+            <a:pPr>
+              <a:spcAft>
+                <a:spcPts val="1200"/>
+              </a:spcAft>
+            </a:pPr>
+            <a:r>
+              <a:rPr sz="1600">
+                <a:solidFill>
+                  <a:srgbClr val="D5DBDB"/>
+                </a:solidFill>
+              </a:rPr>
+              <a:t>Reference accelerator — not an AWS service, not AWS-supported software, not a compliance certification, and not production-ready for regulated data without customer-specific engineering, testing, authorization, and operational ownership.</a:t>
+            </a:r>
+          </a:p>
+          <a:p>
+            <a:pPr>
+              <a:spcAft>
+                <a:spcPts val="1200"/>
+              </a:spcAft>
+            </a:pPr>
+            <a:r>
+              <a:rPr sz="1600">
+                <a:solidFill>
+                  <a:srgbClr val="D5DBDB"/>
+                </a:solidFill>
+              </a:rPr>
+              <a:t>Built on AWS; not affiliated with or endorsed by Amazon Web Services.</a:t>
+            </a:r>
           </a:p>
         </p:txBody>
       </p:sp>

</xml_diff>